<commit_message>
docs: add visual architecture diagram and dedicated architecture slide to clean white presentation deck
</commit_message>
<xml_diff>
--- a/NEXORA_Clean_White_Presentation.pptx
+++ b/NEXORA_Clean_White_Presentation.pptx
@@ -12,6 +12,8 @@
     <p:sldId id="260" r:id="rId11"/>
     <p:sldId id="261" r:id="rId12"/>
     <p:sldId id="262" r:id="rId13"/>
+    <p:sldId id="263" r:id="rId14"/>
+    <p:sldId id="264" r:id="rId15"/>
   </p:sldIdLst>
   <p:sldSz cx="12191695" cy="6858000" type="screen4x3"/>
   <p:notesSz cx="6858000" cy="9144000"/>
@@ -3192,8 +3194,8 @@
         </p:nvSpPr>
         <p:spPr>
           <a:xfrm>
-            <a:off x="914400" y="1005840"/>
-            <a:ext cx="10362895" cy="4937760"/>
+            <a:off x="914400" y="914400"/>
+            <a:ext cx="10362895" cy="5120640"/>
           </a:xfrm>
           <a:prstGeom prst="roundRect">
             <a:avLst/>
@@ -3384,8 +3386,8 @@
         </p:nvSpPr>
         <p:spPr>
           <a:xfrm>
-            <a:off x="822960" y="457200"/>
-            <a:ext cx="10515600" cy="1188720"/>
+            <a:off x="822960" y="411480"/>
+            <a:ext cx="10515600" cy="1097280"/>
           </a:xfrm>
           <a:prstGeom prst="rect">
             <a:avLst/>
@@ -3400,7 +3402,7 @@
           <a:p>
             <a:pPr>
               <a:spcAft>
-                <a:spcPts val="400"/>
+                <a:spcPts val="300"/>
               </a:spcAft>
               <a:defRPr sz="1000" b="1">
                 <a:solidFill>
@@ -3409,7 +3411,7 @@
               </a:defRPr>
             </a:pPr>
             <a:r>
-              <a:t>PROBLEM UNDERSTANDING</a:t>
+              <a:t>PRESENTER DETAILS</a:t>
             </a:r>
           </a:p>
           <a:p>
@@ -3421,13 +3423,13 @@
               </a:defRPr>
             </a:pPr>
             <a:r>
-              <a:t>The Gap in Modern Technical Learning &amp; Career Readiness</a:t>
+              <a:t>Project Presentation Team</a:t>
             </a:r>
           </a:p>
           <a:p>
             <a:pPr>
               <a:spcBef>
-                <a:spcPts val="300"/>
+                <a:spcPts val="200"/>
               </a:spcBef>
               <a:defRPr sz="1150">
                 <a:solidFill>
@@ -3436,7 +3438,7 @@
               </a:defRPr>
             </a:pPr>
             <a:r>
-              <a:t>Understanding the structural pain points that cause 90% of learners to drop out</a:t>
+              <a:t>The innovators behind NEXORA's design and execution</a:t>
             </a:r>
           </a:p>
         </p:txBody>
@@ -3450,7 +3452,7 @@
         <p:spPr>
           <a:xfrm>
             <a:off x="822960" y="1737360"/>
-            <a:ext cx="3383280" cy="4572000"/>
+            <a:ext cx="5120640" cy="4480560"/>
           </a:xfrm>
           <a:prstGeom prst="roundRect">
             <a:avLst/>
@@ -3479,36 +3481,72 @@
           </a:fontRef>
         </p:style>
         <p:txBody>
-          <a:bodyPr rtlCol="0" anchor="ctr" wrap="square" lIns="274320" rIns="274320" tIns="320040"/>
+          <a:bodyPr rtlCol="0" anchor="ctr" wrap="square" lIns="365760" rIns="365760" tIns="365760"/>
           <a:lstStyle/>
           <a:p>
             <a:pPr algn="ctr">
               <a:spcAft>
-                <a:spcPts val="1200"/>
+                <a:spcPts val="800"/>
               </a:spcAft>
+              <a:defRPr sz="1100" b="1">
+                <a:solidFill>
+                  <a:srgbClr val="4F46E5"/>
+                </a:solidFill>
+              </a:defRPr>
+            </a:pPr>
+            <a:r>
+              <a:t>TEAM DETAILS</a:t>
+            </a:r>
+          </a:p>
+          <a:p>
+            <a:pPr>
+              <a:defRPr sz="1300">
+                <a:solidFill>
+                  <a:srgbClr val="64748B"/>
+                </a:solidFill>
+              </a:defRPr>
+            </a:pPr>
+            <a:r>
+              <a:t>Team Name:</a:t>
+            </a:r>
+          </a:p>
+          <a:p>
+            <a:pPr>
+              <a:spcAft>
+                <a:spcPts val="2000"/>
+              </a:spcAft>
+              <a:defRPr sz="2400" b="1">
+                <a:solidFill>
+                  <a:srgbClr val="0F172A"/>
+                </a:solidFill>
+              </a:defRPr>
+            </a:pPr>
+            <a:r>
+              <a:t>Talent Innovators</a:t>
+            </a:r>
+          </a:p>
+          <a:p>
+            <a:pPr>
+              <a:defRPr sz="1300">
+                <a:solidFill>
+                  <a:srgbClr val="64748B"/>
+                </a:solidFill>
+              </a:defRPr>
+            </a:pPr>
+            <a:r>
+              <a:t>Project Track / Theme:</a:t>
+            </a:r>
+          </a:p>
+          <a:p>
+            <a:pPr>
               <a:defRPr sz="1500" b="1">
                 <a:solidFill>
-                  <a:srgbClr val="4F46E5"/>
-                </a:solidFill>
-              </a:defRPr>
-            </a:pPr>
-            <a:r>
-              <a:t>The Gap in E-Learning</a:t>
-            </a:r>
-          </a:p>
-          <a:p>
-            <a:pPr>
-              <a:lnSpc>
-                <a:spcPct val="125000"/>
-              </a:lnSpc>
-              <a:defRPr sz="1100">
-                <a:solidFill>
-                  <a:srgbClr val="334155"/>
-                </a:solidFill>
-              </a:defRPr>
-            </a:pPr>
-            <a:r>
-              <a:t>Online learners face severe information overload with thousands of disconnected video tutorials. Finding the exact right courses and sequencing them into an actionable study path is frustrating, time-consuming, and prone to abandonment.</a:t>
+                  <a:srgbClr val="0284C7"/>
+                </a:solidFill>
+              </a:defRPr>
+            </a:pPr>
+            <a:r>
+              <a:t>AI in Education, Adaptive Learning &amp; Career Placement</a:t>
             </a:r>
           </a:p>
         </p:txBody>
@@ -3521,8 +3559,8 @@
         </p:nvSpPr>
         <p:spPr>
           <a:xfrm>
-            <a:off x="4389120" y="1737360"/>
-            <a:ext cx="3383280" cy="4572000"/>
+            <a:off x="6217920" y="1737360"/>
+            <a:ext cx="5166360" cy="4480560"/>
           </a:xfrm>
           <a:prstGeom prst="roundRect">
             <a:avLst/>
@@ -3551,116 +3589,81 @@
           </a:fontRef>
         </p:style>
         <p:txBody>
-          <a:bodyPr rtlCol="0" anchor="ctr" wrap="square" lIns="274320" rIns="274320" tIns="320040"/>
+          <a:bodyPr rtlCol="0" anchor="ctr" wrap="square" lIns="365760" rIns="365760" tIns="365760"/>
           <a:lstStyle/>
           <a:p>
             <a:pPr algn="ctr">
               <a:spcAft>
-                <a:spcPts val="1200"/>
+                <a:spcPts val="1400"/>
               </a:spcAft>
-              <a:defRPr sz="1500" b="1">
-                <a:solidFill>
-                  <a:srgbClr val="0284C7"/>
-                </a:solidFill>
-              </a:defRPr>
-            </a:pPr>
-            <a:r>
-              <a:t>Core Pain Points</a:t>
+              <a:defRPr sz="1100" b="1">
+                <a:solidFill>
+                  <a:srgbClr val="0D9488"/>
+                </a:solidFill>
+              </a:defRPr>
+            </a:pPr>
+            <a:r>
+              <a:t>TEAM MEMBERS</a:t>
             </a:r>
           </a:p>
           <a:p>
             <a:pPr>
-              <a:lnSpc>
-                <a:spcPct val="125000"/>
-              </a:lnSpc>
-              <a:defRPr sz="1100">
-                <a:solidFill>
-                  <a:srgbClr val="334155"/>
-                </a:solidFill>
-              </a:defRPr>
-            </a:pPr>
-            <a:r>
-              <a:t>• Lack of Goal Alignment: Generic courses ignore student starting baselines.</a:t>
-            </a:r>
-            <a:br/>
-            <a:r>
-              <a:t>• Absence of Prerequisite Clarity: Students fail advanced topics due to unassessed foundation gaps.</a:t>
-            </a:r>
-            <a:br/>
-            <a:r>
-              <a:t>• No Accountability: Zero real-time diagnostic feedback or personalized next steps.</a:t>
-            </a:r>
-          </a:p>
-        </p:txBody>
-      </p:sp>
-      <p:sp>
-        <p:nvSpPr>
-          <p:cNvPr id="6" name="Rounded Rectangle 5"/>
-          <p:cNvSpPr/>
-          <p:nvPr/>
-        </p:nvSpPr>
-        <p:spPr>
-          <a:xfrm>
-            <a:off x="7955279" y="1737360"/>
-            <a:ext cx="3383280" cy="4572000"/>
-          </a:xfrm>
-          <a:prstGeom prst="roundRect">
-            <a:avLst/>
-          </a:prstGeom>
-          <a:solidFill>
-            <a:srgbClr val="FFFFFF"/>
-          </a:solidFill>
-          <a:ln>
-            <a:solidFill>
-              <a:srgbClr val="E2E8F0"/>
-            </a:solidFill>
-          </a:ln>
-        </p:spPr>
-        <p:style>
-          <a:lnRef idx="1">
-            <a:schemeClr val="accent1"/>
-          </a:lnRef>
-          <a:fillRef idx="3">
-            <a:schemeClr val="accent1"/>
-          </a:fillRef>
-          <a:effectRef idx="2">
-            <a:schemeClr val="accent1"/>
-          </a:effectRef>
-          <a:fontRef idx="minor">
-            <a:schemeClr val="lt1"/>
-          </a:fontRef>
-        </p:style>
-        <p:txBody>
-          <a:bodyPr rtlCol="0" anchor="ctr" wrap="square" lIns="274320" rIns="274320" tIns="320040"/>
-          <a:lstStyle/>
-          <a:p>
-            <a:pPr algn="ctr">
               <a:spcAft>
-                <a:spcPts val="1200"/>
+                <a:spcPts val="1600"/>
               </a:spcAft>
-              <a:defRPr sz="1500" b="1">
-                <a:solidFill>
-                  <a:srgbClr val="0D9488"/>
-                </a:solidFill>
-              </a:defRPr>
-            </a:pPr>
-            <a:r>
-              <a:t>Our Core Mission</a:t>
+              <a:defRPr sz="1300">
+                <a:solidFill>
+                  <a:srgbClr val="0F172A"/>
+                </a:solidFill>
+              </a:defRPr>
+            </a:pPr>
+            <a:r>
+              <a:t>1.  ___________________________________  (Team Lead)</a:t>
             </a:r>
           </a:p>
           <a:p>
             <a:pPr>
-              <a:lnSpc>
-                <a:spcPct val="125000"/>
-              </a:lnSpc>
-              <a:defRPr sz="1100">
-                <a:solidFill>
-                  <a:srgbClr val="334155"/>
-                </a:solidFill>
-              </a:defRPr>
-            </a:pPr>
-            <a:r>
-              <a:t>Build an intelligent SaaS platform that dynamically recommends courses, explains technical relevance using Google Gemini LLMs, visualizes prerequisite dependency DAGs, and generates adaptive daily milestones.</a:t>
+              <a:spcAft>
+                <a:spcPts val="1600"/>
+              </a:spcAft>
+              <a:defRPr sz="1300">
+                <a:solidFill>
+                  <a:srgbClr val="0F172A"/>
+                </a:solidFill>
+              </a:defRPr>
+            </a:pPr>
+            <a:r>
+              <a:t>2.  ___________________________________  (Developer / AI)</a:t>
+            </a:r>
+          </a:p>
+          <a:p>
+            <a:pPr>
+              <a:spcAft>
+                <a:spcPts val="1600"/>
+              </a:spcAft>
+              <a:defRPr sz="1300">
+                <a:solidFill>
+                  <a:srgbClr val="0F172A"/>
+                </a:solidFill>
+              </a:defRPr>
+            </a:pPr>
+            <a:r>
+              <a:t>3.  ___________________________________  (Developer / UI)</a:t>
+            </a:r>
+          </a:p>
+          <a:p>
+            <a:pPr>
+              <a:spcAft>
+                <a:spcPts val="1600"/>
+              </a:spcAft>
+              <a:defRPr sz="1300">
+                <a:solidFill>
+                  <a:srgbClr val="0F172A"/>
+                </a:solidFill>
+              </a:defRPr>
+            </a:pPr>
+            <a:r>
+              <a:t>4.  ___________________________________  (Research / QA)</a:t>
             </a:r>
           </a:p>
         </p:txBody>
@@ -3736,8 +3739,8 @@
         </p:nvSpPr>
         <p:spPr>
           <a:xfrm>
-            <a:off x="822960" y="457200"/>
-            <a:ext cx="10515600" cy="1188720"/>
+            <a:off x="822960" y="411480"/>
+            <a:ext cx="10515600" cy="1097280"/>
           </a:xfrm>
           <a:prstGeom prst="rect">
             <a:avLst/>
@@ -3752,7 +3755,7 @@
           <a:p>
             <a:pPr>
               <a:spcAft>
-                <a:spcPts val="400"/>
+                <a:spcPts val="300"/>
               </a:spcAft>
               <a:defRPr sz="1000" b="1">
                 <a:solidFill>
@@ -3761,7 +3764,7 @@
               </a:defRPr>
             </a:pPr>
             <a:r>
-              <a:t>SOLUTION APPROACH</a:t>
+              <a:t>PROBLEM UNDERSTANDING</a:t>
             </a:r>
           </a:p>
           <a:p>
@@ -3773,13 +3776,13 @@
               </a:defRPr>
             </a:pPr>
             <a:r>
-              <a:t>How NEXORA Solves Curriculum Sequencing</a:t>
+              <a:t>The Gap in Modern Technical Learning &amp; Career Readiness</a:t>
             </a:r>
           </a:p>
           <a:p>
             <a:pPr>
               <a:spcBef>
-                <a:spcPts val="300"/>
+                <a:spcPts val="200"/>
               </a:spcBef>
               <a:defRPr sz="1150">
                 <a:solidFill>
@@ -3788,7 +3791,7 @@
               </a:defRPr>
             </a:pPr>
             <a:r>
-              <a:t>An end-to-end adaptive framework guiding learners from goal intake to recruiter readiness</a:t>
+              <a:t>Understanding the structural pain points that cause 90% of learners to drop out</a:t>
             </a:r>
           </a:p>
         </p:txBody>
@@ -3801,8 +3804,8 @@
         </p:nvSpPr>
         <p:spPr>
           <a:xfrm>
-            <a:off x="822960" y="1737360"/>
-            <a:ext cx="5166360" cy="2103120"/>
+            <a:off x="822960" y="1645920"/>
+            <a:ext cx="3383280" cy="4663440"/>
           </a:xfrm>
           <a:prstGeom prst="roundRect">
             <a:avLst/>
@@ -3831,27 +3834,27 @@
           </a:fontRef>
         </p:style>
         <p:txBody>
-          <a:bodyPr rtlCol="0" anchor="ctr" wrap="square" lIns="274320" rIns="274320" tIns="228600"/>
+          <a:bodyPr rtlCol="0" anchor="ctr" wrap="square" lIns="274320" rIns="274320" tIns="320040"/>
           <a:lstStyle/>
           <a:p>
             <a:pPr algn="ctr">
               <a:spcAft>
-                <a:spcPts val="800"/>
+                <a:spcPts val="1200"/>
               </a:spcAft>
-              <a:defRPr sz="1450" b="1">
+              <a:defRPr sz="1500" b="1">
                 <a:solidFill>
                   <a:srgbClr val="4F46E5"/>
                 </a:solidFill>
               </a:defRPr>
             </a:pPr>
             <a:r>
-              <a:t>1. Smart Goal Matching</a:t>
+              <a:t>The Gap in E-Learning</a:t>
             </a:r>
           </a:p>
           <a:p>
             <a:pPr>
               <a:lnSpc>
-                <a:spcPct val="120000"/>
+                <a:spcPct val="125000"/>
               </a:lnSpc>
               <a:defRPr sz="1100">
                 <a:solidFill>
@@ -3860,7 +3863,7 @@
               </a:defRPr>
             </a:pPr>
             <a:r>
-              <a:t>Synthesizes natural language inputs (voice/text) into tailored goal profiles (SWE, AI/ML, JEE, NEET, Data Science, Career Switch), matching learners directly to curated high-yield topics.</a:t>
+              <a:t>Online learners face severe information overload with thousands of disconnected video tutorials. Finding the exact right courses and sequencing them into an actionable study path is frustrating, time-consuming, and prone to abandonment.</a:t>
             </a:r>
           </a:p>
         </p:txBody>
@@ -3873,8 +3876,8 @@
         </p:nvSpPr>
         <p:spPr>
           <a:xfrm>
-            <a:off x="6172200" y="1737360"/>
-            <a:ext cx="5166360" cy="2103120"/>
+            <a:off x="4389120" y="1645920"/>
+            <a:ext cx="3383280" cy="4663440"/>
           </a:xfrm>
           <a:prstGeom prst="roundRect">
             <a:avLst/>
@@ -3903,27 +3906,27 @@
           </a:fontRef>
         </p:style>
         <p:txBody>
-          <a:bodyPr rtlCol="0" anchor="ctr" wrap="square" lIns="274320" rIns="274320" tIns="228600"/>
+          <a:bodyPr rtlCol="0" anchor="ctr" wrap="square" lIns="274320" rIns="274320" tIns="320040"/>
           <a:lstStyle/>
           <a:p>
             <a:pPr algn="ctr">
               <a:spcAft>
-                <a:spcPts val="800"/>
+                <a:spcPts val="1200"/>
               </a:spcAft>
-              <a:defRPr sz="1450" b="1">
+              <a:defRPr sz="1500" b="1">
                 <a:solidFill>
                   <a:srgbClr val="0284C7"/>
                 </a:solidFill>
               </a:defRPr>
             </a:pPr>
             <a:r>
-              <a:t>2. Real-Time Explanation Engine</a:t>
+              <a:t>Core Pain Points</a:t>
             </a:r>
           </a:p>
           <a:p>
             <a:pPr>
               <a:lnSpc>
-                <a:spcPct val="120000"/>
+                <a:spcPct val="125000"/>
               </a:lnSpc>
               <a:defRPr sz="1100">
                 <a:solidFill>
@@ -3932,7 +3935,15 @@
               </a:defRPr>
             </a:pPr>
             <a:r>
-              <a:t>Curriculum analysis breaking down every milestone into prerequisites, core conceptual topics, verified free learning resources, and capstone project blueprints.</a:t>
+              <a:t>• Lack of Goal Alignment: Generic courses ignore student starting baselines.</a:t>
+            </a:r>
+            <a:br/>
+            <a:r>
+              <a:t>• Absence of Prerequisite Clarity: Students fail advanced topics due to unassessed foundation gaps.</a:t>
+            </a:r>
+            <a:br/>
+            <a:r>
+              <a:t>• No Accountability: Zero real-time diagnostic feedback or personalized next steps.</a:t>
             </a:r>
           </a:p>
         </p:txBody>
@@ -3945,8 +3956,8 @@
         </p:nvSpPr>
         <p:spPr>
           <a:xfrm>
-            <a:off x="822960" y="4023360"/>
-            <a:ext cx="5166360" cy="2103120"/>
+            <a:off x="7955279" y="1645920"/>
+            <a:ext cx="3383280" cy="4663440"/>
           </a:xfrm>
           <a:prstGeom prst="roundRect">
             <a:avLst/>
@@ -3975,27 +3986,27 @@
           </a:fontRef>
         </p:style>
         <p:txBody>
-          <a:bodyPr rtlCol="0" anchor="ctr" wrap="square" lIns="274320" rIns="274320" tIns="228600"/>
+          <a:bodyPr rtlCol="0" anchor="ctr" wrap="square" lIns="274320" rIns="274320" tIns="320040"/>
           <a:lstStyle/>
           <a:p>
             <a:pPr algn="ctr">
               <a:spcAft>
-                <a:spcPts val="800"/>
+                <a:spcPts val="1200"/>
               </a:spcAft>
-              <a:defRPr sz="1450" b="1">
+              <a:defRPr sz="1500" b="1">
                 <a:solidFill>
                   <a:srgbClr val="0D9488"/>
                 </a:solidFill>
               </a:defRPr>
             </a:pPr>
             <a:r>
-              <a:t>3. Dynamic DAG Sequencing</a:t>
+              <a:t>Our Core Mission</a:t>
             </a:r>
           </a:p>
           <a:p>
             <a:pPr>
               <a:lnSpc>
-                <a:spcPct val="120000"/>
+                <a:spcPct val="125000"/>
               </a:lnSpc>
               <a:defRPr sz="1100">
                 <a:solidFill>
@@ -4004,79 +4015,7 @@
               </a:defRPr>
             </a:pPr>
             <a:r>
-              <a:t>Generates topological Directed Acyclic Graphs with strict node status tracking (Completed, In Progress, Unlocked, Locked, Remediation) based on real-time diagnostic performance.</a:t>
-            </a:r>
-          </a:p>
-        </p:txBody>
-      </p:sp>
-      <p:sp>
-        <p:nvSpPr>
-          <p:cNvPr id="7" name="Rounded Rectangle 6"/>
-          <p:cNvSpPr/>
-          <p:nvPr/>
-        </p:nvSpPr>
-        <p:spPr>
-          <a:xfrm>
-            <a:off x="6172200" y="4023360"/>
-            <a:ext cx="5166360" cy="2103120"/>
-          </a:xfrm>
-          <a:prstGeom prst="roundRect">
-            <a:avLst/>
-          </a:prstGeom>
-          <a:solidFill>
-            <a:srgbClr val="FFFFFF"/>
-          </a:solidFill>
-          <a:ln>
-            <a:solidFill>
-              <a:srgbClr val="E2E8F0"/>
-            </a:solidFill>
-          </a:ln>
-        </p:spPr>
-        <p:style>
-          <a:lnRef idx="1">
-            <a:schemeClr val="accent1"/>
-          </a:lnRef>
-          <a:fillRef idx="3">
-            <a:schemeClr val="accent1"/>
-          </a:fillRef>
-          <a:effectRef idx="2">
-            <a:schemeClr val="accent1"/>
-          </a:effectRef>
-          <a:fontRef idx="minor">
-            <a:schemeClr val="lt1"/>
-          </a:fontRef>
-        </p:style>
-        <p:txBody>
-          <a:bodyPr rtlCol="0" anchor="ctr" wrap="square" lIns="274320" rIns="274320" tIns="228600"/>
-          <a:lstStyle/>
-          <a:p>
-            <a:pPr algn="ctr">
-              <a:spcAft>
-                <a:spcPts val="800"/>
-              </a:spcAft>
-              <a:defRPr sz="1450" b="1">
-                <a:solidFill>
-                  <a:srgbClr val="0F172A"/>
-                </a:solidFill>
-              </a:defRPr>
-            </a:pPr>
-            <a:r>
-              <a:t>4. Secure Workspaces &amp; ATS Readiness</a:t>
-            </a:r>
-          </a:p>
-          <a:p>
-            <a:pPr>
-              <a:lnSpc>
-                <a:spcPct val="120000"/>
-              </a:lnSpc>
-              <a:defRPr sz="1100">
-                <a:solidFill>
-                  <a:srgbClr val="334155"/>
-                </a:solidFill>
-              </a:defRPr>
-            </a:pPr>
-            <a:r>
-              <a:t>Zero-latency client persistent session with optional Firebase Cloud sync, paired with an automated ATS resume builder calculating real-time recruiter match scores.</a:t>
+              <a:t>Build an intelligent SaaS platform that dynamically recommends courses, explains technical relevance using Google Gemini LLMs, visualizes prerequisite dependency DAGs, and generates adaptive daily milestones.</a:t>
             </a:r>
           </a:p>
         </p:txBody>
@@ -4152,8 +4091,8 @@
         </p:nvSpPr>
         <p:spPr>
           <a:xfrm>
-            <a:off x="822960" y="457200"/>
-            <a:ext cx="10515600" cy="1188720"/>
+            <a:off x="822960" y="411480"/>
+            <a:ext cx="10515600" cy="1097280"/>
           </a:xfrm>
           <a:prstGeom prst="rect">
             <a:avLst/>
@@ -4168,7 +4107,7 @@
           <a:p>
             <a:pPr>
               <a:spcAft>
-                <a:spcPts val="400"/>
+                <a:spcPts val="300"/>
               </a:spcAft>
               <a:defRPr sz="1000" b="1">
                 <a:solidFill>
@@ -4177,7 +4116,7 @@
               </a:defRPr>
             </a:pPr>
             <a:r>
-              <a:t>SYSTEM ARCHITECTURE</a:t>
+              <a:t>SOLUTION APPROACH</a:t>
             </a:r>
           </a:p>
           <a:p>
@@ -4189,13 +4128,13 @@
               </a:defRPr>
             </a:pPr>
             <a:r>
-              <a:t>High-Performance Modular Tech Stack</a:t>
+              <a:t>How NEXORA Solves Curriculum Sequencing</a:t>
             </a:r>
           </a:p>
           <a:p>
             <a:pPr>
               <a:spcBef>
-                <a:spcPts val="300"/>
+                <a:spcPts val="200"/>
               </a:spcBef>
               <a:defRPr sz="1150">
                 <a:solidFill>
@@ -4204,7 +4143,7 @@
               </a:defRPr>
             </a:pPr>
             <a:r>
-              <a:t>Modern client-side architecture backed by generative AI and persistent storage</a:t>
+              <a:t>An end-to-end adaptive framework guiding learners from goal intake to recruiter readiness</a:t>
             </a:r>
           </a:p>
         </p:txBody>
@@ -4217,8 +4156,8 @@
         </p:nvSpPr>
         <p:spPr>
           <a:xfrm>
-            <a:off x="822960" y="1737360"/>
-            <a:ext cx="5166360" cy="2103120"/>
+            <a:off x="822960" y="1645920"/>
+            <a:ext cx="5166360" cy="2148840"/>
           </a:xfrm>
           <a:prstGeom prst="roundRect">
             <a:avLst/>
@@ -4247,48 +4186,36 @@
           </a:fontRef>
         </p:style>
         <p:txBody>
-          <a:bodyPr rtlCol="0" anchor="ctr" wrap="square" lIns="274320" rIns="274320" tIns="201168"/>
+          <a:bodyPr rtlCol="0" anchor="ctr" wrap="square" lIns="274320" rIns="274320" tIns="228600"/>
           <a:lstStyle/>
           <a:p>
             <a:pPr algn="ctr">
               <a:spcAft>
-                <a:spcPts val="600"/>
+                <a:spcPts val="800"/>
               </a:spcAft>
-              <a:defRPr sz="1400" b="1">
+              <a:defRPr sz="1450" b="1">
                 <a:solidFill>
                   <a:srgbClr val="4F46E5"/>
                 </a:solidFill>
               </a:defRPr>
             </a:pPr>
             <a:r>
-              <a:t>Frontend Application Layer</a:t>
+              <a:t>1. Smart Goal Matching</a:t>
             </a:r>
           </a:p>
           <a:p>
             <a:pPr>
               <a:lnSpc>
-                <a:spcPct val="118000"/>
+                <a:spcPct val="120000"/>
               </a:lnSpc>
-              <a:defRPr sz="1050">
+              <a:defRPr sz="1100">
                 <a:solidFill>
                   <a:srgbClr val="334155"/>
                 </a:solidFill>
               </a:defRPr>
             </a:pPr>
             <a:r>
-              <a:t>• React 19 &amp; TypeScript for strict end-to-end type safety.</a:t>
-            </a:r>
-            <a:br/>
-            <a:r>
-              <a:t>• TailwindCSS with clean executive design tokens and Lucide Icons.</a:t>
-            </a:r>
-            <a:br/>
-            <a:r>
-              <a:t>• Web Speech API for voice requirement gathering &amp; chat speech-to-text.</a:t>
-            </a:r>
-            <a:br/>
-            <a:r>
-              <a:t>• Responsive single-page application with zero-latency tab navigation.</a:t>
+              <a:t>Synthesizes natural language inputs (voice/text) into tailored goal profiles (SWE, AI/ML, JEE, NEET, Data Science, Career Switch), matching learners directly to curated high-yield topics.</a:t>
             </a:r>
           </a:p>
         </p:txBody>
@@ -4301,8 +4228,8 @@
         </p:nvSpPr>
         <p:spPr>
           <a:xfrm>
-            <a:off x="6172200" y="1737360"/>
-            <a:ext cx="5166360" cy="2103120"/>
+            <a:off x="6172200" y="1645920"/>
+            <a:ext cx="5166360" cy="2148840"/>
           </a:xfrm>
           <a:prstGeom prst="roundRect">
             <a:avLst/>
@@ -4331,48 +4258,36 @@
           </a:fontRef>
         </p:style>
         <p:txBody>
-          <a:bodyPr rtlCol="0" anchor="ctr" wrap="square" lIns="274320" rIns="274320" tIns="201168"/>
+          <a:bodyPr rtlCol="0" anchor="ctr" wrap="square" lIns="274320" rIns="274320" tIns="228600"/>
           <a:lstStyle/>
           <a:p>
             <a:pPr algn="ctr">
               <a:spcAft>
-                <a:spcPts val="600"/>
+                <a:spcPts val="800"/>
               </a:spcAft>
-              <a:defRPr sz="1400" b="1">
+              <a:defRPr sz="1450" b="1">
                 <a:solidFill>
                   <a:srgbClr val="0284C7"/>
                 </a:solidFill>
               </a:defRPr>
             </a:pPr>
             <a:r>
-              <a:t>Adaptive Engine &amp; Algorithms</a:t>
+              <a:t>2. Real-Time Explanation Engine</a:t>
             </a:r>
           </a:p>
           <a:p>
             <a:pPr>
               <a:lnSpc>
-                <a:spcPct val="118000"/>
+                <a:spcPct val="120000"/>
               </a:lnSpc>
-              <a:defRPr sz="1050">
+              <a:defRPr sz="1100">
                 <a:solidFill>
                   <a:srgbClr val="334155"/>
                 </a:solidFill>
               </a:defRPr>
             </a:pPr>
             <a:r>
-              <a:t>• Directed Acyclic Graph (DAG) Engine with topological prerequisite sorting.</a:t>
-            </a:r>
-            <a:br/>
-            <a:r>
-              <a:t>• Automated Diagnostic Skill Gap Scorer calculating mastery vs benchmarks.</a:t>
-            </a:r>
-            <a:br/>
-            <a:r>
-              <a:t>• Next-Best-Action (NBA) Scorer computing single highest-leverage task.</a:t>
-            </a:r>
-            <a:br/>
-            <a:r>
-              <a:t>• What-If Monte-Carlo Timeline Simulator modeling pacing shifts.</a:t>
+              <a:t>Curriculum analysis breaking down every milestone into prerequisites, core conceptual topics, verified free learning resources, and capstone project blueprints.</a:t>
             </a:r>
           </a:p>
         </p:txBody>
@@ -4385,8 +4300,8 @@
         </p:nvSpPr>
         <p:spPr>
           <a:xfrm>
-            <a:off x="822960" y="4023360"/>
-            <a:ext cx="5166360" cy="2103120"/>
+            <a:off x="822960" y="3977639"/>
+            <a:ext cx="5166360" cy="2148840"/>
           </a:xfrm>
           <a:prstGeom prst="roundRect">
             <a:avLst/>
@@ -4415,48 +4330,36 @@
           </a:fontRef>
         </p:style>
         <p:txBody>
-          <a:bodyPr rtlCol="0" anchor="ctr" wrap="square" lIns="274320" rIns="274320" tIns="201168"/>
+          <a:bodyPr rtlCol="0" anchor="ctr" wrap="square" lIns="274320" rIns="274320" tIns="228600"/>
           <a:lstStyle/>
           <a:p>
             <a:pPr algn="ctr">
               <a:spcAft>
-                <a:spcPts val="600"/>
+                <a:spcPts val="800"/>
               </a:spcAft>
-              <a:defRPr sz="1400" b="1">
+              <a:defRPr sz="1450" b="1">
                 <a:solidFill>
                   <a:srgbClr val="0D9488"/>
                 </a:solidFill>
               </a:defRPr>
             </a:pPr>
             <a:r>
-              <a:t>AI Services &amp; LLM Layer</a:t>
+              <a:t>3. Dynamic DAG Sequencing</a:t>
             </a:r>
           </a:p>
           <a:p>
             <a:pPr>
               <a:lnSpc>
-                <a:spcPct val="118000"/>
+                <a:spcPct val="120000"/>
               </a:lnSpc>
-              <a:defRPr sz="1050">
+              <a:defRPr sz="1100">
                 <a:solidFill>
                   <a:srgbClr val="334155"/>
                 </a:solidFill>
               </a:defRPr>
             </a:pPr>
             <a:r>
-              <a:t>• Google Gemini 1.5 Flash &amp; 2.0 API with multi-turn conversational reasoning.</a:t>
-            </a:r>
-            <a:br/>
-            <a:r>
-              <a:t>• Dynamic system prompt pipeline injected with student profile &amp; milestones.</a:t>
-            </a:r>
-            <a:br/>
-            <a:r>
-              <a:t>• Resilient offline semantic intent classifier for instant fallback answers.</a:t>
-            </a:r>
-            <a:br/>
-            <a:r>
-              <a:t>• Dynamic MCQ assessment generator for custom skills.</a:t>
+              <a:t>Generates topological Directed Acyclic Graphs with strict node status tracking (Completed, In Progress, Unlocked, Locked, Remediation) based on real-time diagnostic performance.</a:t>
             </a:r>
           </a:p>
         </p:txBody>
@@ -4469,8 +4372,8 @@
         </p:nvSpPr>
         <p:spPr>
           <a:xfrm>
-            <a:off x="6172200" y="4023360"/>
-            <a:ext cx="5166360" cy="2103120"/>
+            <a:off x="6172200" y="3977639"/>
+            <a:ext cx="5166360" cy="2148840"/>
           </a:xfrm>
           <a:prstGeom prst="roundRect">
             <a:avLst/>
@@ -4499,48 +4402,36 @@
           </a:fontRef>
         </p:style>
         <p:txBody>
-          <a:bodyPr rtlCol="0" anchor="ctr" wrap="square" lIns="274320" rIns="274320" tIns="201168"/>
+          <a:bodyPr rtlCol="0" anchor="ctr" wrap="square" lIns="274320" rIns="274320" tIns="228600"/>
           <a:lstStyle/>
           <a:p>
             <a:pPr algn="ctr">
               <a:spcAft>
-                <a:spcPts val="600"/>
+                <a:spcPts val="800"/>
               </a:spcAft>
-              <a:defRPr sz="1400" b="1">
+              <a:defRPr sz="1450" b="1">
                 <a:solidFill>
                   <a:srgbClr val="0F172A"/>
                 </a:solidFill>
               </a:defRPr>
             </a:pPr>
             <a:r>
-              <a:t>Storage, Export &amp; Deployment</a:t>
+              <a:t>4. Secure Workspaces &amp; ATS Readiness</a:t>
             </a:r>
           </a:p>
           <a:p>
             <a:pPr>
               <a:lnSpc>
-                <a:spcPct val="118000"/>
+                <a:spcPct val="120000"/>
               </a:lnSpc>
-              <a:defRPr sz="1050">
+              <a:defRPr sz="1100">
                 <a:solidFill>
                   <a:srgbClr val="334155"/>
                 </a:solidFill>
               </a:defRPr>
             </a:pPr>
             <a:r>
-              <a:t>• LocalStorage Persistent Engine for instant offline session caching.</a:t>
-            </a:r>
-            <a:br/>
-            <a:r>
-              <a:t>• Firebase Cloud Auth &amp; Cloud Firestore profile sync (Optional).</a:t>
-            </a:r>
-            <a:br/>
-            <a:r>
-              <a:t>• jsPDF &amp; jsPDF-AutoTable for instantaneous ATS Resume PDF generation.</a:t>
-            </a:r>
-            <a:br/>
-            <a:r>
-              <a:t>• Continuous Deployment Pipeline: GitHub auto-deployed via Vercel.</a:t>
+              <a:t>Zero-latency client persistent session with optional Firebase Cloud sync, paired with an automated ATS resume builder calculating real-time recruiter match scores.</a:t>
             </a:r>
           </a:p>
         </p:txBody>
@@ -4616,8 +4507,8 @@
         </p:nvSpPr>
         <p:spPr>
           <a:xfrm>
-            <a:off x="822960" y="457200"/>
-            <a:ext cx="10515600" cy="1188720"/>
+            <a:off x="822960" y="411480"/>
+            <a:ext cx="10515600" cy="1097280"/>
           </a:xfrm>
           <a:prstGeom prst="rect">
             <a:avLst/>
@@ -4632,7 +4523,7 @@
           <a:p>
             <a:pPr>
               <a:spcAft>
-                <a:spcPts val="400"/>
+                <a:spcPts val="300"/>
               </a:spcAft>
               <a:defRPr sz="1000" b="1">
                 <a:solidFill>
@@ -4641,7 +4532,7 @@
               </a:defRPr>
             </a:pPr>
             <a:r>
-              <a:t>AI &amp; ML TECHNIQUES</a:t>
+              <a:t>SYSTEM ARCHITECTURE DIAGRAM</a:t>
             </a:r>
           </a:p>
           <a:p>
@@ -4653,13 +4544,13 @@
               </a:defRPr>
             </a:pPr>
             <a:r>
-              <a:t>Core Machine Learning &amp; LLM Implementations</a:t>
+              <a:t>Visual End-to-End System Architecture</a:t>
             </a:r>
           </a:p>
           <a:p>
             <a:pPr>
               <a:spcBef>
-                <a:spcPts val="300"/>
+                <a:spcPts val="200"/>
               </a:spcBef>
               <a:defRPr sz="1150">
                 <a:solidFill>
@@ -4668,299 +4559,35 @@
               </a:defRPr>
             </a:pPr>
             <a:r>
-              <a:t>How generative intelligence and topological graphs deliver customized learning</a:t>
-            </a:r>
-          </a:p>
-        </p:txBody>
-      </p:sp>
-      <p:sp>
-        <p:nvSpPr>
-          <p:cNvPr id="4" name="Rounded Rectangle 3"/>
-          <p:cNvSpPr/>
+              <a:t>Dataflow across UI presentation, adaptive engines, Gemini LLM reasoning, and cloud persistence</a:t>
+            </a:r>
+          </a:p>
+        </p:txBody>
+      </p:sp>
+      <p:pic>
+        <p:nvPicPr>
+          <p:cNvPr id="4" name="Picture 3" descr="nexora_architecture_diagram.png"/>
+          <p:cNvPicPr>
+            <a:picLocks noChangeAspect="1"/>
+          </p:cNvPicPr>
           <p:nvPr/>
-        </p:nvSpPr>
-        <p:spPr>
-          <a:xfrm>
-            <a:off x="822960" y="1737360"/>
-            <a:ext cx="5166360" cy="2103120"/>
-          </a:xfrm>
-          <a:prstGeom prst="roundRect">
+        </p:nvPicPr>
+        <p:blipFill>
+          <a:blip r:embed="rId2"/>
+          <a:stretch>
+            <a:fillRect/>
+          </a:stretch>
+        </p:blipFill>
+        <p:spPr>
+          <a:xfrm>
+            <a:off x="822960" y="1554480"/>
+            <a:ext cx="10545775" cy="4846320"/>
+          </a:xfrm>
+          <a:prstGeom prst="rect">
             <a:avLst/>
           </a:prstGeom>
-          <a:solidFill>
-            <a:srgbClr val="FFFFFF"/>
-          </a:solidFill>
-          <a:ln>
-            <a:solidFill>
-              <a:srgbClr val="E2E8F0"/>
-            </a:solidFill>
-          </a:ln>
-        </p:spPr>
-        <p:style>
-          <a:lnRef idx="1">
-            <a:schemeClr val="accent1"/>
-          </a:lnRef>
-          <a:fillRef idx="3">
-            <a:schemeClr val="accent1"/>
-          </a:fillRef>
-          <a:effectRef idx="2">
-            <a:schemeClr val="accent1"/>
-          </a:effectRef>
-          <a:fontRef idx="minor">
-            <a:schemeClr val="lt1"/>
-          </a:fontRef>
-        </p:style>
-        <p:txBody>
-          <a:bodyPr rtlCol="0" anchor="ctr" wrap="square" lIns="274320" rIns="274320" tIns="201168"/>
-          <a:lstStyle/>
-          <a:p>
-            <a:pPr algn="ctr">
-              <a:spcAft>
-                <a:spcPts val="600"/>
-              </a:spcAft>
-              <a:defRPr sz="1400" b="1">
-                <a:solidFill>
-                  <a:srgbClr val="4F46E5"/>
-                </a:solidFill>
-              </a:defRPr>
-            </a:pPr>
-            <a:r>
-              <a:t>1. Large Language Model Integration</a:t>
-            </a:r>
-          </a:p>
-          <a:p>
-            <a:pPr>
-              <a:lnSpc>
-                <a:spcPct val="120000"/>
-              </a:lnSpc>
-              <a:defRPr sz="1050">
-                <a:solidFill>
-                  <a:srgbClr val="334155"/>
-                </a:solidFill>
-              </a:defRPr>
-            </a:pPr>
-            <a:r>
-              <a:t>Integrated Google Gemini 1.5 Flash and 2.0 API with dynamic context injection. Sends full user state (Target Goal, Completed Milestones, Active Skill Gaps, Pacing) to generate tailored conversational guidance, code examples, and doubt resolution.</a:t>
-            </a:r>
-          </a:p>
-        </p:txBody>
-      </p:sp>
-      <p:sp>
-        <p:nvSpPr>
-          <p:cNvPr id="5" name="Rounded Rectangle 4"/>
-          <p:cNvSpPr/>
-          <p:nvPr/>
-        </p:nvSpPr>
-        <p:spPr>
-          <a:xfrm>
-            <a:off x="6172200" y="1737360"/>
-            <a:ext cx="5166360" cy="2103120"/>
-          </a:xfrm>
-          <a:prstGeom prst="roundRect">
-            <a:avLst/>
-          </a:prstGeom>
-          <a:solidFill>
-            <a:srgbClr val="FFFFFF"/>
-          </a:solidFill>
-          <a:ln>
-            <a:solidFill>
-              <a:srgbClr val="E2E8F0"/>
-            </a:solidFill>
-          </a:ln>
-        </p:spPr>
-        <p:style>
-          <a:lnRef idx="1">
-            <a:schemeClr val="accent1"/>
-          </a:lnRef>
-          <a:fillRef idx="3">
-            <a:schemeClr val="accent1"/>
-          </a:fillRef>
-          <a:effectRef idx="2">
-            <a:schemeClr val="accent1"/>
-          </a:effectRef>
-          <a:fontRef idx="minor">
-            <a:schemeClr val="lt1"/>
-          </a:fontRef>
-        </p:style>
-        <p:txBody>
-          <a:bodyPr rtlCol="0" anchor="ctr" wrap="square" lIns="274320" rIns="274320" tIns="201168"/>
-          <a:lstStyle/>
-          <a:p>
-            <a:pPr algn="ctr">
-              <a:spcAft>
-                <a:spcPts val="600"/>
-              </a:spcAft>
-              <a:defRPr sz="1400" b="1">
-                <a:solidFill>
-                  <a:srgbClr val="0284C7"/>
-                </a:solidFill>
-              </a:defRPr>
-            </a:pPr>
-            <a:r>
-              <a:t>2. Topological Graph Traversal (DAG)</a:t>
-            </a:r>
-          </a:p>
-          <a:p>
-            <a:pPr>
-              <a:lnSpc>
-                <a:spcPct val="120000"/>
-              </a:lnSpc>
-              <a:defRPr sz="1050">
-                <a:solidFill>
-                  <a:srgbClr val="334155"/>
-                </a:solidFill>
-              </a:defRPr>
-            </a:pPr>
-            <a:r>
-              <a:t>Implements graph-theoretic dependency trees where skills represent nodes and prerequisites represent directed edges. Automatically triggers remedial sub-branches when assessment scores drop below mastery benchmarks (70%).</a:t>
-            </a:r>
-          </a:p>
-        </p:txBody>
-      </p:sp>
-      <p:sp>
-        <p:nvSpPr>
-          <p:cNvPr id="6" name="Rounded Rectangle 5"/>
-          <p:cNvSpPr/>
-          <p:nvPr/>
-        </p:nvSpPr>
-        <p:spPr>
-          <a:xfrm>
-            <a:off x="822960" y="4023360"/>
-            <a:ext cx="5166360" cy="2103120"/>
-          </a:xfrm>
-          <a:prstGeom prst="roundRect">
-            <a:avLst/>
-          </a:prstGeom>
-          <a:solidFill>
-            <a:srgbClr val="FFFFFF"/>
-          </a:solidFill>
-          <a:ln>
-            <a:solidFill>
-              <a:srgbClr val="E2E8F0"/>
-            </a:solidFill>
-          </a:ln>
-        </p:spPr>
-        <p:style>
-          <a:lnRef idx="1">
-            <a:schemeClr val="accent1"/>
-          </a:lnRef>
-          <a:fillRef idx="3">
-            <a:schemeClr val="accent1"/>
-          </a:fillRef>
-          <a:effectRef idx="2">
-            <a:schemeClr val="accent1"/>
-          </a:effectRef>
-          <a:fontRef idx="minor">
-            <a:schemeClr val="lt1"/>
-          </a:fontRef>
-        </p:style>
-        <p:txBody>
-          <a:bodyPr rtlCol="0" anchor="ctr" wrap="square" lIns="274320" rIns="274320" tIns="201168"/>
-          <a:lstStyle/>
-          <a:p>
-            <a:pPr algn="ctr">
-              <a:spcAft>
-                <a:spcPts val="600"/>
-              </a:spcAft>
-              <a:defRPr sz="1400" b="1">
-                <a:solidFill>
-                  <a:srgbClr val="0D9488"/>
-                </a:solidFill>
-              </a:defRPr>
-            </a:pPr>
-            <a:r>
-              <a:t>3. Structured Output &amp; JSON Enforcement</a:t>
-            </a:r>
-          </a:p>
-          <a:p>
-            <a:pPr>
-              <a:lnSpc>
-                <a:spcPct val="120000"/>
-              </a:lnSpc>
-              <a:defRPr sz="1050">
-                <a:solidFill>
-                  <a:srgbClr val="334155"/>
-                </a:solidFill>
-              </a:defRPr>
-            </a:pPr>
-            <a:r>
-              <a:t>Utilizes strict JSON schema prompting to dynamically generate 8-step roadmap milestones, goal-specific challenge vectors, and diagnostic multiple-choice assessments on the fly.</a:t>
-            </a:r>
-          </a:p>
-        </p:txBody>
-      </p:sp>
-      <p:sp>
-        <p:nvSpPr>
-          <p:cNvPr id="7" name="Rounded Rectangle 6"/>
-          <p:cNvSpPr/>
-          <p:nvPr/>
-        </p:nvSpPr>
-        <p:spPr>
-          <a:xfrm>
-            <a:off x="6172200" y="4023360"/>
-            <a:ext cx="5166360" cy="2103120"/>
-          </a:xfrm>
-          <a:prstGeom prst="roundRect">
-            <a:avLst/>
-          </a:prstGeom>
-          <a:solidFill>
-            <a:srgbClr val="FFFFFF"/>
-          </a:solidFill>
-          <a:ln>
-            <a:solidFill>
-              <a:srgbClr val="E2E8F0"/>
-            </a:solidFill>
-          </a:ln>
-        </p:spPr>
-        <p:style>
-          <a:lnRef idx="1">
-            <a:schemeClr val="accent1"/>
-          </a:lnRef>
-          <a:fillRef idx="3">
-            <a:schemeClr val="accent1"/>
-          </a:fillRef>
-          <a:effectRef idx="2">
-            <a:schemeClr val="accent1"/>
-          </a:effectRef>
-          <a:fontRef idx="minor">
-            <a:schemeClr val="lt1"/>
-          </a:fontRef>
-        </p:style>
-        <p:txBody>
-          <a:bodyPr rtlCol="0" anchor="ctr" wrap="square" lIns="274320" rIns="274320" tIns="201168"/>
-          <a:lstStyle/>
-          <a:p>
-            <a:pPr algn="ctr">
-              <a:spcAft>
-                <a:spcPts val="600"/>
-              </a:spcAft>
-              <a:defRPr sz="1400" b="1">
-                <a:solidFill>
-                  <a:srgbClr val="0F172A"/>
-                </a:solidFill>
-              </a:defRPr>
-            </a:pPr>
-            <a:r>
-              <a:t>4. Latency Management &amp; Offline Intelligence</a:t>
-            </a:r>
-          </a:p>
-          <a:p>
-            <a:pPr>
-              <a:lnSpc>
-                <a:spcPct val="120000"/>
-              </a:lnSpc>
-              <a:defRPr sz="1050">
-                <a:solidFill>
-                  <a:srgbClr val="334155"/>
-                </a:solidFill>
-              </a:defRPr>
-            </a:pPr>
-            <a:r>
-              <a:t>Features multi-tiered execution with fast 4-second timeout handling and a semantic intent classifier capable of addressing technical comparisons (e.g. Web Dev vs ML), OOP, and DSA offline without freezing.</a:t>
-            </a:r>
-          </a:p>
-        </p:txBody>
-      </p:sp>
+        </p:spPr>
+      </p:pic>
     </p:spTree>
   </p:cSld>
   <p:clrMapOvr>
@@ -5032,8 +4659,8 @@
         </p:nvSpPr>
         <p:spPr>
           <a:xfrm>
-            <a:off x="822960" y="457200"/>
-            <a:ext cx="10515600" cy="1188720"/>
+            <a:off x="822960" y="411480"/>
+            <a:ext cx="10515600" cy="1097280"/>
           </a:xfrm>
           <a:prstGeom prst="rect">
             <a:avLst/>
@@ -5048,7 +4675,7 @@
           <a:p>
             <a:pPr>
               <a:spcAft>
-                <a:spcPts val="400"/>
+                <a:spcPts val="300"/>
               </a:spcAft>
               <a:defRPr sz="1000" b="1">
                 <a:solidFill>
@@ -5057,7 +4684,7 @@
               </a:defRPr>
             </a:pPr>
             <a:r>
-              <a:t>PRODUCT FEATURES</a:t>
+              <a:t>TECHNICAL EXECUTION</a:t>
             </a:r>
           </a:p>
           <a:p>
@@ -5069,13 +4696,13 @@
               </a:defRPr>
             </a:pPr>
             <a:r>
-              <a:t>Key Features &amp; Core User Workflows</a:t>
+              <a:t>Architectural Stack &amp; System Components</a:t>
             </a:r>
           </a:p>
           <a:p>
             <a:pPr>
               <a:spcBef>
-                <a:spcPts val="300"/>
+                <a:spcPts val="200"/>
               </a:spcBef>
               <a:defRPr sz="1150">
                 <a:solidFill>
@@ -5084,7 +4711,7 @@
               </a:defRPr>
             </a:pPr>
             <a:r>
-              <a:t>Comprehensive suite of integrated tools designed for continuous student mastery</a:t>
+              <a:t>Detailed technical specifications of the 4 core layers</a:t>
             </a:r>
           </a:p>
         </p:txBody>
@@ -5097,8 +4724,8 @@
         </p:nvSpPr>
         <p:spPr>
           <a:xfrm>
-            <a:off x="822960" y="1737360"/>
-            <a:ext cx="2514600" cy="2103120"/>
+            <a:off x="822960" y="1645920"/>
+            <a:ext cx="5166360" cy="2148840"/>
           </a:xfrm>
           <a:prstGeom prst="roundRect">
             <a:avLst/>
@@ -5127,36 +4754,48 @@
           </a:fontRef>
         </p:style>
         <p:txBody>
-          <a:bodyPr rtlCol="0" anchor="ctr" wrap="square" lIns="182880" rIns="182880" tIns="182880"/>
+          <a:bodyPr rtlCol="0" anchor="ctr" wrap="square" lIns="274320" rIns="274320" tIns="201168"/>
           <a:lstStyle/>
           <a:p>
             <a:pPr algn="ctr">
               <a:spcAft>
                 <a:spcPts val="600"/>
               </a:spcAft>
-              <a:defRPr sz="1200" b="1">
+              <a:defRPr sz="1400" b="1">
                 <a:solidFill>
                   <a:srgbClr val="4F46E5"/>
                 </a:solidFill>
               </a:defRPr>
             </a:pPr>
             <a:r>
-              <a:t>AI Conversational Onboarding</a:t>
+              <a:t>Frontend Application Layer</a:t>
             </a:r>
           </a:p>
           <a:p>
             <a:pPr>
               <a:lnSpc>
-                <a:spcPct val="115000"/>
+                <a:spcPct val="118000"/>
               </a:lnSpc>
-              <a:defRPr sz="1000">
+              <a:defRPr sz="1050">
                 <a:solidFill>
                   <a:srgbClr val="334155"/>
                 </a:solidFill>
               </a:defRPr>
             </a:pPr>
             <a:r>
-              <a:t>Interactive voice &amp; text interface gathering user goals, time availability, and background.</a:t>
+              <a:t>• React 19 &amp; TypeScript for strict end-to-end type safety.</a:t>
+            </a:r>
+            <a:br/>
+            <a:r>
+              <a:t>• TailwindCSS with clean executive design tokens and Lucide Icons.</a:t>
+            </a:r>
+            <a:br/>
+            <a:r>
+              <a:t>• Web Speech API for voice requirement gathering &amp; chat speech-to-text.</a:t>
+            </a:r>
+            <a:br/>
+            <a:r>
+              <a:t>• Responsive single-page application with zero-latency tab navigation.</a:t>
             </a:r>
           </a:p>
         </p:txBody>
@@ -5169,8 +4808,8 @@
         </p:nvSpPr>
         <p:spPr>
           <a:xfrm>
-            <a:off x="3474720" y="1737360"/>
-            <a:ext cx="2514600" cy="2103120"/>
+            <a:off x="6172200" y="1645920"/>
+            <a:ext cx="5166360" cy="2148840"/>
           </a:xfrm>
           <a:prstGeom prst="roundRect">
             <a:avLst/>
@@ -5199,36 +4838,48 @@
           </a:fontRef>
         </p:style>
         <p:txBody>
-          <a:bodyPr rtlCol="0" anchor="ctr" wrap="square" lIns="182880" rIns="182880" tIns="182880"/>
+          <a:bodyPr rtlCol="0" anchor="ctr" wrap="square" lIns="274320" rIns="274320" tIns="201168"/>
           <a:lstStyle/>
           <a:p>
             <a:pPr algn="ctr">
               <a:spcAft>
                 <a:spcPts val="600"/>
               </a:spcAft>
-              <a:defRPr sz="1200" b="1">
+              <a:defRPr sz="1400" b="1">
                 <a:solidFill>
                   <a:srgbClr val="0284C7"/>
                 </a:solidFill>
               </a:defRPr>
             </a:pPr>
             <a:r>
-              <a:t>Interactive Flowchart DAG</a:t>
+              <a:t>Adaptive Engine &amp; Algorithms</a:t>
             </a:r>
           </a:p>
           <a:p>
             <a:pPr>
               <a:lnSpc>
-                <a:spcPct val="115000"/>
+                <a:spcPct val="118000"/>
               </a:lnSpc>
-              <a:defRPr sz="1000">
+              <a:defRPr sz="1050">
                 <a:solidFill>
                   <a:srgbClr val="334155"/>
                 </a:solidFill>
               </a:defRPr>
             </a:pPr>
             <a:r>
-              <a:t>Visual dependency roadmap with clickable nodes, learning objectives, and status tags.</a:t>
+              <a:t>• Directed Acyclic Graph (DAG) Engine with topological prerequisite sorting.</a:t>
+            </a:r>
+            <a:br/>
+            <a:r>
+              <a:t>• Automated Diagnostic Skill Gap Scorer calculating mastery vs benchmarks.</a:t>
+            </a:r>
+            <a:br/>
+            <a:r>
+              <a:t>• Next-Best-Action (NBA) Scorer computing single highest-leverage task.</a:t>
+            </a:r>
+            <a:br/>
+            <a:r>
+              <a:t>• What-If Monte-Carlo Timeline Simulator modeling pacing shifts.</a:t>
             </a:r>
           </a:p>
         </p:txBody>
@@ -5241,8 +4892,8 @@
         </p:nvSpPr>
         <p:spPr>
           <a:xfrm>
-            <a:off x="6126480" y="1737360"/>
-            <a:ext cx="2514600" cy="2103120"/>
+            <a:off x="822960" y="3977639"/>
+            <a:ext cx="5166360" cy="2148840"/>
           </a:xfrm>
           <a:prstGeom prst="roundRect">
             <a:avLst/>
@@ -5271,36 +4922,48 @@
           </a:fontRef>
         </p:style>
         <p:txBody>
-          <a:bodyPr rtlCol="0" anchor="ctr" wrap="square" lIns="182880" rIns="182880" tIns="182880"/>
+          <a:bodyPr rtlCol="0" anchor="ctr" wrap="square" lIns="274320" rIns="274320" tIns="201168"/>
           <a:lstStyle/>
           <a:p>
             <a:pPr algn="ctr">
               <a:spcAft>
                 <a:spcPts val="600"/>
               </a:spcAft>
-              <a:defRPr sz="1200" b="1">
+              <a:defRPr sz="1400" b="1">
                 <a:solidFill>
                   <a:srgbClr val="0D9488"/>
                 </a:solidFill>
               </a:defRPr>
             </a:pPr>
             <a:r>
-              <a:t>Automated Diagnostic Engine</a:t>
+              <a:t>AI Services &amp; LLM Layer</a:t>
             </a:r>
           </a:p>
           <a:p>
             <a:pPr>
               <a:lnSpc>
-                <a:spcPct val="115000"/>
+                <a:spcPct val="118000"/>
               </a:lnSpc>
-              <a:defRPr sz="1000">
+              <a:defRPr sz="1050">
                 <a:solidFill>
                   <a:srgbClr val="334155"/>
                 </a:solidFill>
               </a:defRPr>
             </a:pPr>
             <a:r>
-              <a:t>Benchmark-driven MCQ quizzes that calculate real-time mastery percentages per skill.</a:t>
+              <a:t>• Google Gemini 1.5 Flash &amp; 2.0 API with multi-turn conversational reasoning.</a:t>
+            </a:r>
+            <a:br/>
+            <a:r>
+              <a:t>• Dynamic system prompt pipeline injected with student profile &amp; milestones.</a:t>
+            </a:r>
+            <a:br/>
+            <a:r>
+              <a:t>• Resilient offline semantic intent classifier for instant fallback answers.</a:t>
+            </a:r>
+            <a:br/>
+            <a:r>
+              <a:t>• Dynamic MCQ assessment generator for custom skills.</a:t>
             </a:r>
           </a:p>
         </p:txBody>
@@ -5313,8 +4976,8 @@
         </p:nvSpPr>
         <p:spPr>
           <a:xfrm>
-            <a:off x="8778240" y="1737360"/>
-            <a:ext cx="2514600" cy="2103120"/>
+            <a:off x="6172200" y="3977639"/>
+            <a:ext cx="5166360" cy="2148840"/>
           </a:xfrm>
           <a:prstGeom prst="roundRect">
             <a:avLst/>
@@ -5343,324 +5006,48 @@
           </a:fontRef>
         </p:style>
         <p:txBody>
-          <a:bodyPr rtlCol="0" anchor="ctr" wrap="square" lIns="182880" rIns="182880" tIns="182880"/>
+          <a:bodyPr rtlCol="0" anchor="ctr" wrap="square" lIns="274320" rIns="274320" tIns="201168"/>
           <a:lstStyle/>
           <a:p>
             <a:pPr algn="ctr">
               <a:spcAft>
                 <a:spcPts val="600"/>
               </a:spcAft>
-              <a:defRPr sz="1200" b="1">
+              <a:defRPr sz="1400" b="1">
                 <a:solidFill>
                   <a:srgbClr val="0F172A"/>
                 </a:solidFill>
               </a:defRPr>
             </a:pPr>
             <a:r>
-              <a:t>Next-Best-Action (NBA)</a:t>
+              <a:t>Storage, Export &amp; Deployment</a:t>
             </a:r>
           </a:p>
           <a:p>
             <a:pPr>
               <a:lnSpc>
-                <a:spcPct val="115000"/>
+                <a:spcPct val="118000"/>
               </a:lnSpc>
-              <a:defRPr sz="1000">
+              <a:defRPr sz="1050">
                 <a:solidFill>
                   <a:srgbClr val="334155"/>
                 </a:solidFill>
               </a:defRPr>
             </a:pPr>
             <a:r>
-              <a:t>Algorithmic decision engine computing the single highest-yield study task for today.</a:t>
-            </a:r>
-          </a:p>
-        </p:txBody>
-      </p:sp>
-      <p:sp>
-        <p:nvSpPr>
-          <p:cNvPr id="8" name="Rounded Rectangle 7"/>
-          <p:cNvSpPr/>
-          <p:nvPr/>
-        </p:nvSpPr>
-        <p:spPr>
-          <a:xfrm>
-            <a:off x="822960" y="4023360"/>
-            <a:ext cx="2514600" cy="2103120"/>
-          </a:xfrm>
-          <a:prstGeom prst="roundRect">
-            <a:avLst/>
-          </a:prstGeom>
-          <a:solidFill>
-            <a:srgbClr val="FFFFFF"/>
-          </a:solidFill>
-          <a:ln>
-            <a:solidFill>
-              <a:srgbClr val="E2E8F0"/>
-            </a:solidFill>
-          </a:ln>
-        </p:spPr>
-        <p:style>
-          <a:lnRef idx="1">
-            <a:schemeClr val="accent1"/>
-          </a:lnRef>
-          <a:fillRef idx="3">
-            <a:schemeClr val="accent1"/>
-          </a:fillRef>
-          <a:effectRef idx="2">
-            <a:schemeClr val="accent1"/>
-          </a:effectRef>
-          <a:fontRef idx="minor">
-            <a:schemeClr val="lt1"/>
-          </a:fontRef>
-        </p:style>
-        <p:txBody>
-          <a:bodyPr rtlCol="0" anchor="ctr" wrap="square" lIns="182880" rIns="182880" tIns="182880"/>
-          <a:lstStyle/>
-          <a:p>
-            <a:pPr algn="ctr">
-              <a:spcAft>
-                <a:spcPts val="600"/>
-              </a:spcAft>
-              <a:defRPr sz="1200" b="1">
-                <a:solidFill>
-                  <a:srgbClr val="4F46E5"/>
-                </a:solidFill>
-              </a:defRPr>
-            </a:pPr>
-            <a:r>
-              <a:t>24/7 Context-Aware AI Chatbot</a:t>
-            </a:r>
-          </a:p>
-          <a:p>
-            <a:pPr>
-              <a:lnSpc>
-                <a:spcPct val="115000"/>
-              </a:lnSpc>
-              <a:defRPr sz="1000">
-                <a:solidFill>
-                  <a:srgbClr val="334155"/>
-                </a:solidFill>
-              </a:defRPr>
-            </a:pPr>
-            <a:r>
-              <a:t>Intelligent tutor providing code blocks with copy buttons, comparisons, and exam tips.</a:t>
-            </a:r>
-          </a:p>
-        </p:txBody>
-      </p:sp>
-      <p:sp>
-        <p:nvSpPr>
-          <p:cNvPr id="9" name="Rounded Rectangle 8"/>
-          <p:cNvSpPr/>
-          <p:nvPr/>
-        </p:nvSpPr>
-        <p:spPr>
-          <a:xfrm>
-            <a:off x="3474720" y="4023360"/>
-            <a:ext cx="2514600" cy="2103120"/>
-          </a:xfrm>
-          <a:prstGeom prst="roundRect">
-            <a:avLst/>
-          </a:prstGeom>
-          <a:solidFill>
-            <a:srgbClr val="FFFFFF"/>
-          </a:solidFill>
-          <a:ln>
-            <a:solidFill>
-              <a:srgbClr val="E2E8F0"/>
-            </a:solidFill>
-          </a:ln>
-        </p:spPr>
-        <p:style>
-          <a:lnRef idx="1">
-            <a:schemeClr val="accent1"/>
-          </a:lnRef>
-          <a:fillRef idx="3">
-            <a:schemeClr val="accent1"/>
-          </a:fillRef>
-          <a:effectRef idx="2">
-            <a:schemeClr val="accent1"/>
-          </a:effectRef>
-          <a:fontRef idx="minor">
-            <a:schemeClr val="lt1"/>
-          </a:fontRef>
-        </p:style>
-        <p:txBody>
-          <a:bodyPr rtlCol="0" anchor="ctr" wrap="square" lIns="182880" rIns="182880" tIns="182880"/>
-          <a:lstStyle/>
-          <a:p>
-            <a:pPr algn="ctr">
-              <a:spcAft>
-                <a:spcPts val="600"/>
-              </a:spcAft>
-              <a:defRPr sz="1200" b="1">
-                <a:solidFill>
-                  <a:srgbClr val="0284C7"/>
-                </a:solidFill>
-              </a:defRPr>
-            </a:pPr>
-            <a:r>
-              <a:t>ATS Resume Builder &amp; Scoring</a:t>
-            </a:r>
-          </a:p>
-          <a:p>
-            <a:pPr>
-              <a:lnSpc>
-                <a:spcPct val="115000"/>
-              </a:lnSpc>
-              <a:defRPr sz="1000">
-                <a:solidFill>
-                  <a:srgbClr val="334155"/>
-                </a:solidFill>
-              </a:defRPr>
-            </a:pPr>
-            <a:r>
-              <a:t>Instant ATS score calculation, Google XYZ bullet optimizers, and 1-click PDF download.</a:t>
-            </a:r>
-          </a:p>
-        </p:txBody>
-      </p:sp>
-      <p:sp>
-        <p:nvSpPr>
-          <p:cNvPr id="10" name="Rounded Rectangle 9"/>
-          <p:cNvSpPr/>
-          <p:nvPr/>
-        </p:nvSpPr>
-        <p:spPr>
-          <a:xfrm>
-            <a:off x="6126480" y="4023360"/>
-            <a:ext cx="2514600" cy="2103120"/>
-          </a:xfrm>
-          <a:prstGeom prst="roundRect">
-            <a:avLst/>
-          </a:prstGeom>
-          <a:solidFill>
-            <a:srgbClr val="FFFFFF"/>
-          </a:solidFill>
-          <a:ln>
-            <a:solidFill>
-              <a:srgbClr val="E2E8F0"/>
-            </a:solidFill>
-          </a:ln>
-        </p:spPr>
-        <p:style>
-          <a:lnRef idx="1">
-            <a:schemeClr val="accent1"/>
-          </a:lnRef>
-          <a:fillRef idx="3">
-            <a:schemeClr val="accent1"/>
-          </a:fillRef>
-          <a:effectRef idx="2">
-            <a:schemeClr val="accent1"/>
-          </a:effectRef>
-          <a:fontRef idx="minor">
-            <a:schemeClr val="lt1"/>
-          </a:fontRef>
-        </p:style>
-        <p:txBody>
-          <a:bodyPr rtlCol="0" anchor="ctr" wrap="square" lIns="182880" rIns="182880" tIns="182880"/>
-          <a:lstStyle/>
-          <a:p>
-            <a:pPr algn="ctr">
-              <a:spcAft>
-                <a:spcPts val="600"/>
-              </a:spcAft>
-              <a:defRPr sz="1200" b="1">
-                <a:solidFill>
-                  <a:srgbClr val="0D9488"/>
-                </a:solidFill>
-              </a:defRPr>
-            </a:pPr>
-            <a:r>
-              <a:t>What-If Scenario Simulator</a:t>
-            </a:r>
-          </a:p>
-          <a:p>
-            <a:pPr>
-              <a:lnSpc>
-                <a:spcPct val="115000"/>
-              </a:lnSpc>
-              <a:defRPr sz="1000">
-                <a:solidFill>
-                  <a:srgbClr val="334155"/>
-                </a:solidFill>
-              </a:defRPr>
-            </a:pPr>
-            <a:r>
-              <a:t>Interactive time-commitment slider modeling how study pacing impacts target completion.</a:t>
-            </a:r>
-          </a:p>
-        </p:txBody>
-      </p:sp>
-      <p:sp>
-        <p:nvSpPr>
-          <p:cNvPr id="11" name="Rounded Rectangle 10"/>
-          <p:cNvSpPr/>
-          <p:nvPr/>
-        </p:nvSpPr>
-        <p:spPr>
-          <a:xfrm>
-            <a:off x="8778240" y="4023360"/>
-            <a:ext cx="2514600" cy="2103120"/>
-          </a:xfrm>
-          <a:prstGeom prst="roundRect">
-            <a:avLst/>
-          </a:prstGeom>
-          <a:solidFill>
-            <a:srgbClr val="FFFFFF"/>
-          </a:solidFill>
-          <a:ln>
-            <a:solidFill>
-              <a:srgbClr val="E2E8F0"/>
-            </a:solidFill>
-          </a:ln>
-        </p:spPr>
-        <p:style>
-          <a:lnRef idx="1">
-            <a:schemeClr val="accent1"/>
-          </a:lnRef>
-          <a:fillRef idx="3">
-            <a:schemeClr val="accent1"/>
-          </a:fillRef>
-          <a:effectRef idx="2">
-            <a:schemeClr val="accent1"/>
-          </a:effectRef>
-          <a:fontRef idx="minor">
-            <a:schemeClr val="lt1"/>
-          </a:fontRef>
-        </p:style>
-        <p:txBody>
-          <a:bodyPr rtlCol="0" anchor="ctr" wrap="square" lIns="182880" rIns="182880" tIns="182880"/>
-          <a:lstStyle/>
-          <a:p>
-            <a:pPr algn="ctr">
-              <a:spcAft>
-                <a:spcPts val="600"/>
-              </a:spcAft>
-              <a:defRPr sz="1200" b="1">
-                <a:solidFill>
-                  <a:srgbClr val="0F172A"/>
-                </a:solidFill>
-              </a:defRPr>
-            </a:pPr>
-            <a:r>
-              <a:t>100% Free Resources Catalog</a:t>
-            </a:r>
-          </a:p>
-          <a:p>
-            <a:pPr>
-              <a:lnSpc>
-                <a:spcPct val="115000"/>
-              </a:lnSpc>
-              <a:defRPr sz="1000">
-                <a:solidFill>
-                  <a:srgbClr val="334155"/>
-                </a:solidFill>
-              </a:defRPr>
-            </a:pPr>
-            <a:r>
-              <a:t>Curated zero-cost materials from MIT OpenCourseWare, CS50, Disha, HCV, &amp; freeCodeCamp.</a:t>
+              <a:t>• LocalStorage Persistent Engine for instant offline session caching.</a:t>
+            </a:r>
+            <a:br/>
+            <a:r>
+              <a:t>• Firebase Cloud Auth &amp; Cloud Firestore profile sync (Optional).</a:t>
+            </a:r>
+            <a:br/>
+            <a:r>
+              <a:t>• jsPDF &amp; jsPDF-AutoTable for instantaneous ATS Resume PDF generation.</a:t>
+            </a:r>
+            <a:br/>
+            <a:r>
+              <a:t>• Continuous Deployment Pipeline: GitHub auto-deployed via Vercel.</a:t>
             </a:r>
           </a:p>
         </p:txBody>
@@ -5730,14 +5117,1134 @@
       </p:sp>
       <p:sp>
         <p:nvSpPr>
+          <p:cNvPr id="3" name="TextBox 2"/>
+          <p:cNvSpPr txBox="1"/>
+          <p:nvPr/>
+        </p:nvSpPr>
+        <p:spPr>
+          <a:xfrm>
+            <a:off x="822960" y="411480"/>
+            <a:ext cx="10515600" cy="1097280"/>
+          </a:xfrm>
+          <a:prstGeom prst="rect">
+            <a:avLst/>
+          </a:prstGeom>
+          <a:noFill/>
+        </p:spPr>
+        <p:txBody>
+          <a:bodyPr wrap="square" lIns="0" tIns="0" rIns="0" bIns="0">
+            <a:spAutoFit/>
+          </a:bodyPr>
+          <a:lstStyle/>
+          <a:p>
+            <a:pPr>
+              <a:spcAft>
+                <a:spcPts val="300"/>
+              </a:spcAft>
+              <a:defRPr sz="1000" b="1">
+                <a:solidFill>
+                  <a:srgbClr val="4F46E5"/>
+                </a:solidFill>
+              </a:defRPr>
+            </a:pPr>
+            <a:r>
+              <a:t>AI &amp; ML TECHNIQUES</a:t>
+            </a:r>
+          </a:p>
+          <a:p>
+            <a:pPr>
+              <a:defRPr sz="2200" b="1">
+                <a:solidFill>
+                  <a:srgbClr val="0F172A"/>
+                </a:solidFill>
+              </a:defRPr>
+            </a:pPr>
+            <a:r>
+              <a:t>Core Machine Learning &amp; LLM Implementations</a:t>
+            </a:r>
+          </a:p>
+          <a:p>
+            <a:pPr>
+              <a:spcBef>
+                <a:spcPts val="200"/>
+              </a:spcBef>
+              <a:defRPr sz="1150">
+                <a:solidFill>
+                  <a:srgbClr val="64748B"/>
+                </a:solidFill>
+              </a:defRPr>
+            </a:pPr>
+            <a:r>
+              <a:t>How generative intelligence and topological graphs deliver customized learning</a:t>
+            </a:r>
+          </a:p>
+        </p:txBody>
+      </p:sp>
+      <p:sp>
+        <p:nvSpPr>
+          <p:cNvPr id="4" name="Rounded Rectangle 3"/>
+          <p:cNvSpPr/>
+          <p:nvPr/>
+        </p:nvSpPr>
+        <p:spPr>
+          <a:xfrm>
+            <a:off x="822960" y="1645920"/>
+            <a:ext cx="5166360" cy="2148840"/>
+          </a:xfrm>
+          <a:prstGeom prst="roundRect">
+            <a:avLst/>
+          </a:prstGeom>
+          <a:solidFill>
+            <a:srgbClr val="FFFFFF"/>
+          </a:solidFill>
+          <a:ln>
+            <a:solidFill>
+              <a:srgbClr val="E2E8F0"/>
+            </a:solidFill>
+          </a:ln>
+        </p:spPr>
+        <p:style>
+          <a:lnRef idx="1">
+            <a:schemeClr val="accent1"/>
+          </a:lnRef>
+          <a:fillRef idx="3">
+            <a:schemeClr val="accent1"/>
+          </a:fillRef>
+          <a:effectRef idx="2">
+            <a:schemeClr val="accent1"/>
+          </a:effectRef>
+          <a:fontRef idx="minor">
+            <a:schemeClr val="lt1"/>
+          </a:fontRef>
+        </p:style>
+        <p:txBody>
+          <a:bodyPr rtlCol="0" anchor="ctr" wrap="square" lIns="274320" rIns="274320" tIns="201168"/>
+          <a:lstStyle/>
+          <a:p>
+            <a:pPr algn="ctr">
+              <a:spcAft>
+                <a:spcPts val="600"/>
+              </a:spcAft>
+              <a:defRPr sz="1400" b="1">
+                <a:solidFill>
+                  <a:srgbClr val="4F46E5"/>
+                </a:solidFill>
+              </a:defRPr>
+            </a:pPr>
+            <a:r>
+              <a:t>1. Large Language Model Integration</a:t>
+            </a:r>
+          </a:p>
+          <a:p>
+            <a:pPr>
+              <a:lnSpc>
+                <a:spcPct val="120000"/>
+              </a:lnSpc>
+              <a:defRPr sz="1050">
+                <a:solidFill>
+                  <a:srgbClr val="334155"/>
+                </a:solidFill>
+              </a:defRPr>
+            </a:pPr>
+            <a:r>
+              <a:t>Integrated Google Gemini 1.5 Flash and 2.0 API with dynamic context injection. Sends full user state (Target Goal, Completed Milestones, Active Skill Gaps, Pacing) to generate tailored conversational guidance, code examples, and doubt resolution.</a:t>
+            </a:r>
+          </a:p>
+        </p:txBody>
+      </p:sp>
+      <p:sp>
+        <p:nvSpPr>
+          <p:cNvPr id="5" name="Rounded Rectangle 4"/>
+          <p:cNvSpPr/>
+          <p:nvPr/>
+        </p:nvSpPr>
+        <p:spPr>
+          <a:xfrm>
+            <a:off x="6172200" y="1645920"/>
+            <a:ext cx="5166360" cy="2148840"/>
+          </a:xfrm>
+          <a:prstGeom prst="roundRect">
+            <a:avLst/>
+          </a:prstGeom>
+          <a:solidFill>
+            <a:srgbClr val="FFFFFF"/>
+          </a:solidFill>
+          <a:ln>
+            <a:solidFill>
+              <a:srgbClr val="E2E8F0"/>
+            </a:solidFill>
+          </a:ln>
+        </p:spPr>
+        <p:style>
+          <a:lnRef idx="1">
+            <a:schemeClr val="accent1"/>
+          </a:lnRef>
+          <a:fillRef idx="3">
+            <a:schemeClr val="accent1"/>
+          </a:fillRef>
+          <a:effectRef idx="2">
+            <a:schemeClr val="accent1"/>
+          </a:effectRef>
+          <a:fontRef idx="minor">
+            <a:schemeClr val="lt1"/>
+          </a:fontRef>
+        </p:style>
+        <p:txBody>
+          <a:bodyPr rtlCol="0" anchor="ctr" wrap="square" lIns="274320" rIns="274320" tIns="201168"/>
+          <a:lstStyle/>
+          <a:p>
+            <a:pPr algn="ctr">
+              <a:spcAft>
+                <a:spcPts val="600"/>
+              </a:spcAft>
+              <a:defRPr sz="1400" b="1">
+                <a:solidFill>
+                  <a:srgbClr val="0284C7"/>
+                </a:solidFill>
+              </a:defRPr>
+            </a:pPr>
+            <a:r>
+              <a:t>2. Topological Graph Traversal (DAG)</a:t>
+            </a:r>
+          </a:p>
+          <a:p>
+            <a:pPr>
+              <a:lnSpc>
+                <a:spcPct val="120000"/>
+              </a:lnSpc>
+              <a:defRPr sz="1050">
+                <a:solidFill>
+                  <a:srgbClr val="334155"/>
+                </a:solidFill>
+              </a:defRPr>
+            </a:pPr>
+            <a:r>
+              <a:t>Implements graph-theoretic dependency trees where skills represent nodes and prerequisites represent directed edges. Automatically triggers remedial sub-branches when assessment scores drop below threshold benchmarks (70%).</a:t>
+            </a:r>
+          </a:p>
+        </p:txBody>
+      </p:sp>
+      <p:sp>
+        <p:nvSpPr>
+          <p:cNvPr id="6" name="Rounded Rectangle 5"/>
+          <p:cNvSpPr/>
+          <p:nvPr/>
+        </p:nvSpPr>
+        <p:spPr>
+          <a:xfrm>
+            <a:off x="822960" y="3977639"/>
+            <a:ext cx="5166360" cy="2148840"/>
+          </a:xfrm>
+          <a:prstGeom prst="roundRect">
+            <a:avLst/>
+          </a:prstGeom>
+          <a:solidFill>
+            <a:srgbClr val="FFFFFF"/>
+          </a:solidFill>
+          <a:ln>
+            <a:solidFill>
+              <a:srgbClr val="E2E8F0"/>
+            </a:solidFill>
+          </a:ln>
+        </p:spPr>
+        <p:style>
+          <a:lnRef idx="1">
+            <a:schemeClr val="accent1"/>
+          </a:lnRef>
+          <a:fillRef idx="3">
+            <a:schemeClr val="accent1"/>
+          </a:fillRef>
+          <a:effectRef idx="2">
+            <a:schemeClr val="accent1"/>
+          </a:effectRef>
+          <a:fontRef idx="minor">
+            <a:schemeClr val="lt1"/>
+          </a:fontRef>
+        </p:style>
+        <p:txBody>
+          <a:bodyPr rtlCol="0" anchor="ctr" wrap="square" lIns="274320" rIns="274320" tIns="201168"/>
+          <a:lstStyle/>
+          <a:p>
+            <a:pPr algn="ctr">
+              <a:spcAft>
+                <a:spcPts val="600"/>
+              </a:spcAft>
+              <a:defRPr sz="1400" b="1">
+                <a:solidFill>
+                  <a:srgbClr val="0D9488"/>
+                </a:solidFill>
+              </a:defRPr>
+            </a:pPr>
+            <a:r>
+              <a:t>3. Structured Output &amp; JSON Enforcement</a:t>
+            </a:r>
+          </a:p>
+          <a:p>
+            <a:pPr>
+              <a:lnSpc>
+                <a:spcPct val="120000"/>
+              </a:lnSpc>
+              <a:defRPr sz="1050">
+                <a:solidFill>
+                  <a:srgbClr val="334155"/>
+                </a:solidFill>
+              </a:defRPr>
+            </a:pPr>
+            <a:r>
+              <a:t>Utilizes strict JSON schema prompting to dynamically generate 8-step roadmap milestones, goal-specific challenge vectors, and diagnostic multiple-choice assessments on the fly.</a:t>
+            </a:r>
+          </a:p>
+        </p:txBody>
+      </p:sp>
+      <p:sp>
+        <p:nvSpPr>
+          <p:cNvPr id="7" name="Rounded Rectangle 6"/>
+          <p:cNvSpPr/>
+          <p:nvPr/>
+        </p:nvSpPr>
+        <p:spPr>
+          <a:xfrm>
+            <a:off x="6172200" y="3977639"/>
+            <a:ext cx="5166360" cy="2148840"/>
+          </a:xfrm>
+          <a:prstGeom prst="roundRect">
+            <a:avLst/>
+          </a:prstGeom>
+          <a:solidFill>
+            <a:srgbClr val="FFFFFF"/>
+          </a:solidFill>
+          <a:ln>
+            <a:solidFill>
+              <a:srgbClr val="E2E8F0"/>
+            </a:solidFill>
+          </a:ln>
+        </p:spPr>
+        <p:style>
+          <a:lnRef idx="1">
+            <a:schemeClr val="accent1"/>
+          </a:lnRef>
+          <a:fillRef idx="3">
+            <a:schemeClr val="accent1"/>
+          </a:fillRef>
+          <a:effectRef idx="2">
+            <a:schemeClr val="accent1"/>
+          </a:effectRef>
+          <a:fontRef idx="minor">
+            <a:schemeClr val="lt1"/>
+          </a:fontRef>
+        </p:style>
+        <p:txBody>
+          <a:bodyPr rtlCol="0" anchor="ctr" wrap="square" lIns="274320" rIns="274320" tIns="201168"/>
+          <a:lstStyle/>
+          <a:p>
+            <a:pPr algn="ctr">
+              <a:spcAft>
+                <a:spcPts val="600"/>
+              </a:spcAft>
+              <a:defRPr sz="1400" b="1">
+                <a:solidFill>
+                  <a:srgbClr val="0F172A"/>
+                </a:solidFill>
+              </a:defRPr>
+            </a:pPr>
+            <a:r>
+              <a:t>4. Latency Management &amp; Offline Intelligence</a:t>
+            </a:r>
+          </a:p>
+          <a:p>
+            <a:pPr>
+              <a:lnSpc>
+                <a:spcPct val="120000"/>
+              </a:lnSpc>
+              <a:defRPr sz="1050">
+                <a:solidFill>
+                  <a:srgbClr val="334155"/>
+                </a:solidFill>
+              </a:defRPr>
+            </a:pPr>
+            <a:r>
+              <a:t>Features multi-tiered execution with fast 4-second timeout handling and a semantic intent classifier capable of addressing technical comparisons (e.g. Web Dev vs ML), OOP, and DSA offline without freezing.</a:t>
+            </a:r>
+          </a:p>
+        </p:txBody>
+      </p:sp>
+    </p:spTree>
+  </p:cSld>
+  <p:clrMapOvr>
+    <a:masterClrMapping/>
+  </p:clrMapOvr>
+</p:sld>
+</file>
+
+<file path=ppt/slides/slide8.xml><?xml version="1.0" encoding="utf-8"?>
+<p:sld xmlns:a="http://schemas.openxmlformats.org/drawingml/2006/main" xmlns:p="http://schemas.openxmlformats.org/presentationml/2006/main" xmlns:r="http://schemas.openxmlformats.org/officeDocument/2006/relationships">
+  <p:cSld>
+    <p:spTree>
+      <p:nvGrpSpPr>
+        <p:cNvPr id="1" name=""/>
+        <p:cNvGrpSpPr/>
+        <p:nvPr/>
+      </p:nvGrpSpPr>
+      <p:grpSpPr/>
+      <p:sp>
+        <p:nvSpPr>
+          <p:cNvPr id="2" name="Rectangle 1"/>
+          <p:cNvSpPr/>
+          <p:nvPr/>
+        </p:nvSpPr>
+        <p:spPr>
+          <a:xfrm>
+            <a:off x="0" y="0"/>
+            <a:ext cx="12191695" cy="6858000"/>
+          </a:xfrm>
+          <a:prstGeom prst="rect">
+            <a:avLst/>
+          </a:prstGeom>
+          <a:solidFill>
+            <a:srgbClr val="F8FAFC"/>
+          </a:solidFill>
+          <a:ln>
+            <a:solidFill>
+              <a:srgbClr val="F8FAFC"/>
+            </a:solidFill>
+          </a:ln>
+        </p:spPr>
+        <p:style>
+          <a:lnRef idx="1">
+            <a:schemeClr val="accent1"/>
+          </a:lnRef>
+          <a:fillRef idx="3">
+            <a:schemeClr val="accent1"/>
+          </a:fillRef>
+          <a:effectRef idx="2">
+            <a:schemeClr val="accent1"/>
+          </a:effectRef>
+          <a:fontRef idx="minor">
+            <a:schemeClr val="lt1"/>
+          </a:fontRef>
+        </p:style>
+        <p:txBody>
+          <a:bodyPr rtlCol="0" anchor="ctr"/>
+          <a:lstStyle/>
+          <a:p>
+            <a:pPr algn="ctr"/>
+          </a:p>
+        </p:txBody>
+      </p:sp>
+      <p:sp>
+        <p:nvSpPr>
+          <p:cNvPr id="3" name="TextBox 2"/>
+          <p:cNvSpPr txBox="1"/>
+          <p:nvPr/>
+        </p:nvSpPr>
+        <p:spPr>
+          <a:xfrm>
+            <a:off x="822960" y="411480"/>
+            <a:ext cx="10515600" cy="1097280"/>
+          </a:xfrm>
+          <a:prstGeom prst="rect">
+            <a:avLst/>
+          </a:prstGeom>
+          <a:noFill/>
+        </p:spPr>
+        <p:txBody>
+          <a:bodyPr wrap="square" lIns="0" tIns="0" rIns="0" bIns="0">
+            <a:spAutoFit/>
+          </a:bodyPr>
+          <a:lstStyle/>
+          <a:p>
+            <a:pPr>
+              <a:spcAft>
+                <a:spcPts val="300"/>
+              </a:spcAft>
+              <a:defRPr sz="1000" b="1">
+                <a:solidFill>
+                  <a:srgbClr val="4F46E5"/>
+                </a:solidFill>
+              </a:defRPr>
+            </a:pPr>
+            <a:r>
+              <a:t>PRODUCT FEATURES</a:t>
+            </a:r>
+          </a:p>
+          <a:p>
+            <a:pPr>
+              <a:defRPr sz="2200" b="1">
+                <a:solidFill>
+                  <a:srgbClr val="0F172A"/>
+                </a:solidFill>
+              </a:defRPr>
+            </a:pPr>
+            <a:r>
+              <a:t>Key Features &amp; Core User Workflows</a:t>
+            </a:r>
+          </a:p>
+          <a:p>
+            <a:pPr>
+              <a:spcBef>
+                <a:spcPts val="200"/>
+              </a:spcBef>
+              <a:defRPr sz="1150">
+                <a:solidFill>
+                  <a:srgbClr val="64748B"/>
+                </a:solidFill>
+              </a:defRPr>
+            </a:pPr>
+            <a:r>
+              <a:t>Comprehensive suite of integrated tools designed for continuous student mastery</a:t>
+            </a:r>
+          </a:p>
+        </p:txBody>
+      </p:sp>
+      <p:sp>
+        <p:nvSpPr>
+          <p:cNvPr id="4" name="Rounded Rectangle 3"/>
+          <p:cNvSpPr/>
+          <p:nvPr/>
+        </p:nvSpPr>
+        <p:spPr>
+          <a:xfrm>
+            <a:off x="822960" y="1645920"/>
+            <a:ext cx="2514600" cy="2148840"/>
+          </a:xfrm>
+          <a:prstGeom prst="roundRect">
+            <a:avLst/>
+          </a:prstGeom>
+          <a:solidFill>
+            <a:srgbClr val="FFFFFF"/>
+          </a:solidFill>
+          <a:ln>
+            <a:solidFill>
+              <a:srgbClr val="E2E8F0"/>
+            </a:solidFill>
+          </a:ln>
+        </p:spPr>
+        <p:style>
+          <a:lnRef idx="1">
+            <a:schemeClr val="accent1"/>
+          </a:lnRef>
+          <a:fillRef idx="3">
+            <a:schemeClr val="accent1"/>
+          </a:fillRef>
+          <a:effectRef idx="2">
+            <a:schemeClr val="accent1"/>
+          </a:effectRef>
+          <a:fontRef idx="minor">
+            <a:schemeClr val="lt1"/>
+          </a:fontRef>
+        </p:style>
+        <p:txBody>
+          <a:bodyPr rtlCol="0" anchor="ctr" wrap="square" lIns="182880" rIns="182880" tIns="182880"/>
+          <a:lstStyle/>
+          <a:p>
+            <a:pPr algn="ctr">
+              <a:spcAft>
+                <a:spcPts val="600"/>
+              </a:spcAft>
+              <a:defRPr sz="1200" b="1">
+                <a:solidFill>
+                  <a:srgbClr val="4F46E5"/>
+                </a:solidFill>
+              </a:defRPr>
+            </a:pPr>
+            <a:r>
+              <a:t>AI Conversational Onboarding</a:t>
+            </a:r>
+          </a:p>
+          <a:p>
+            <a:pPr>
+              <a:lnSpc>
+                <a:spcPct val="115000"/>
+              </a:lnSpc>
+              <a:defRPr sz="1000">
+                <a:solidFill>
+                  <a:srgbClr val="334155"/>
+                </a:solidFill>
+              </a:defRPr>
+            </a:pPr>
+            <a:r>
+              <a:t>Interactive voice &amp; text interface gathering user goals, time availability, and background.</a:t>
+            </a:r>
+          </a:p>
+        </p:txBody>
+      </p:sp>
+      <p:sp>
+        <p:nvSpPr>
+          <p:cNvPr id="5" name="Rounded Rectangle 4"/>
+          <p:cNvSpPr/>
+          <p:nvPr/>
+        </p:nvSpPr>
+        <p:spPr>
+          <a:xfrm>
+            <a:off x="3474720" y="1645920"/>
+            <a:ext cx="2514600" cy="2148840"/>
+          </a:xfrm>
+          <a:prstGeom prst="roundRect">
+            <a:avLst/>
+          </a:prstGeom>
+          <a:solidFill>
+            <a:srgbClr val="FFFFFF"/>
+          </a:solidFill>
+          <a:ln>
+            <a:solidFill>
+              <a:srgbClr val="E2E8F0"/>
+            </a:solidFill>
+          </a:ln>
+        </p:spPr>
+        <p:style>
+          <a:lnRef idx="1">
+            <a:schemeClr val="accent1"/>
+          </a:lnRef>
+          <a:fillRef idx="3">
+            <a:schemeClr val="accent1"/>
+          </a:fillRef>
+          <a:effectRef idx="2">
+            <a:schemeClr val="accent1"/>
+          </a:effectRef>
+          <a:fontRef idx="minor">
+            <a:schemeClr val="lt1"/>
+          </a:fontRef>
+        </p:style>
+        <p:txBody>
+          <a:bodyPr rtlCol="0" anchor="ctr" wrap="square" lIns="182880" rIns="182880" tIns="182880"/>
+          <a:lstStyle/>
+          <a:p>
+            <a:pPr algn="ctr">
+              <a:spcAft>
+                <a:spcPts val="600"/>
+              </a:spcAft>
+              <a:defRPr sz="1200" b="1">
+                <a:solidFill>
+                  <a:srgbClr val="0284C7"/>
+                </a:solidFill>
+              </a:defRPr>
+            </a:pPr>
+            <a:r>
+              <a:t>Interactive Flowchart DAG</a:t>
+            </a:r>
+          </a:p>
+          <a:p>
+            <a:pPr>
+              <a:lnSpc>
+                <a:spcPct val="115000"/>
+              </a:lnSpc>
+              <a:defRPr sz="1000">
+                <a:solidFill>
+                  <a:srgbClr val="334155"/>
+                </a:solidFill>
+              </a:defRPr>
+            </a:pPr>
+            <a:r>
+              <a:t>Visual dependency roadmap with clickable nodes, learning objectives, and status tags.</a:t>
+            </a:r>
+          </a:p>
+        </p:txBody>
+      </p:sp>
+      <p:sp>
+        <p:nvSpPr>
+          <p:cNvPr id="6" name="Rounded Rectangle 5"/>
+          <p:cNvSpPr/>
+          <p:nvPr/>
+        </p:nvSpPr>
+        <p:spPr>
+          <a:xfrm>
+            <a:off x="6126480" y="1645920"/>
+            <a:ext cx="2514600" cy="2148840"/>
+          </a:xfrm>
+          <a:prstGeom prst="roundRect">
+            <a:avLst/>
+          </a:prstGeom>
+          <a:solidFill>
+            <a:srgbClr val="FFFFFF"/>
+          </a:solidFill>
+          <a:ln>
+            <a:solidFill>
+              <a:srgbClr val="E2E8F0"/>
+            </a:solidFill>
+          </a:ln>
+        </p:spPr>
+        <p:style>
+          <a:lnRef idx="1">
+            <a:schemeClr val="accent1"/>
+          </a:lnRef>
+          <a:fillRef idx="3">
+            <a:schemeClr val="accent1"/>
+          </a:fillRef>
+          <a:effectRef idx="2">
+            <a:schemeClr val="accent1"/>
+          </a:effectRef>
+          <a:fontRef idx="minor">
+            <a:schemeClr val="lt1"/>
+          </a:fontRef>
+        </p:style>
+        <p:txBody>
+          <a:bodyPr rtlCol="0" anchor="ctr" wrap="square" lIns="182880" rIns="182880" tIns="182880"/>
+          <a:lstStyle/>
+          <a:p>
+            <a:pPr algn="ctr">
+              <a:spcAft>
+                <a:spcPts val="600"/>
+              </a:spcAft>
+              <a:defRPr sz="1200" b="1">
+                <a:solidFill>
+                  <a:srgbClr val="0D9488"/>
+                </a:solidFill>
+              </a:defRPr>
+            </a:pPr>
+            <a:r>
+              <a:t>Automated Diagnostic Engine</a:t>
+            </a:r>
+          </a:p>
+          <a:p>
+            <a:pPr>
+              <a:lnSpc>
+                <a:spcPct val="115000"/>
+              </a:lnSpc>
+              <a:defRPr sz="1000">
+                <a:solidFill>
+                  <a:srgbClr val="334155"/>
+                </a:solidFill>
+              </a:defRPr>
+            </a:pPr>
+            <a:r>
+              <a:t>Benchmark-driven MCQ quizzes that calculate real-time mastery percentages per skill.</a:t>
+            </a:r>
+          </a:p>
+        </p:txBody>
+      </p:sp>
+      <p:sp>
+        <p:nvSpPr>
+          <p:cNvPr id="7" name="Rounded Rectangle 6"/>
+          <p:cNvSpPr/>
+          <p:nvPr/>
+        </p:nvSpPr>
+        <p:spPr>
+          <a:xfrm>
+            <a:off x="8778240" y="1645920"/>
+            <a:ext cx="2514600" cy="2148840"/>
+          </a:xfrm>
+          <a:prstGeom prst="roundRect">
+            <a:avLst/>
+          </a:prstGeom>
+          <a:solidFill>
+            <a:srgbClr val="FFFFFF"/>
+          </a:solidFill>
+          <a:ln>
+            <a:solidFill>
+              <a:srgbClr val="E2E8F0"/>
+            </a:solidFill>
+          </a:ln>
+        </p:spPr>
+        <p:style>
+          <a:lnRef idx="1">
+            <a:schemeClr val="accent1"/>
+          </a:lnRef>
+          <a:fillRef idx="3">
+            <a:schemeClr val="accent1"/>
+          </a:fillRef>
+          <a:effectRef idx="2">
+            <a:schemeClr val="accent1"/>
+          </a:effectRef>
+          <a:fontRef idx="minor">
+            <a:schemeClr val="lt1"/>
+          </a:fontRef>
+        </p:style>
+        <p:txBody>
+          <a:bodyPr rtlCol="0" anchor="ctr" wrap="square" lIns="182880" rIns="182880" tIns="182880"/>
+          <a:lstStyle/>
+          <a:p>
+            <a:pPr algn="ctr">
+              <a:spcAft>
+                <a:spcPts val="600"/>
+              </a:spcAft>
+              <a:defRPr sz="1200" b="1">
+                <a:solidFill>
+                  <a:srgbClr val="0F172A"/>
+                </a:solidFill>
+              </a:defRPr>
+            </a:pPr>
+            <a:r>
+              <a:t>Next-Best-Action (NBA)</a:t>
+            </a:r>
+          </a:p>
+          <a:p>
+            <a:pPr>
+              <a:lnSpc>
+                <a:spcPct val="115000"/>
+              </a:lnSpc>
+              <a:defRPr sz="1000">
+                <a:solidFill>
+                  <a:srgbClr val="334155"/>
+                </a:solidFill>
+              </a:defRPr>
+            </a:pPr>
+            <a:r>
+              <a:t>Algorithmic decision engine computing the single highest-yield study task for today.</a:t>
+            </a:r>
+          </a:p>
+        </p:txBody>
+      </p:sp>
+      <p:sp>
+        <p:nvSpPr>
+          <p:cNvPr id="8" name="Rounded Rectangle 7"/>
+          <p:cNvSpPr/>
+          <p:nvPr/>
+        </p:nvSpPr>
+        <p:spPr>
+          <a:xfrm>
+            <a:off x="822960" y="3977639"/>
+            <a:ext cx="2514600" cy="2148840"/>
+          </a:xfrm>
+          <a:prstGeom prst="roundRect">
+            <a:avLst/>
+          </a:prstGeom>
+          <a:solidFill>
+            <a:srgbClr val="FFFFFF"/>
+          </a:solidFill>
+          <a:ln>
+            <a:solidFill>
+              <a:srgbClr val="E2E8F0"/>
+            </a:solidFill>
+          </a:ln>
+        </p:spPr>
+        <p:style>
+          <a:lnRef idx="1">
+            <a:schemeClr val="accent1"/>
+          </a:lnRef>
+          <a:fillRef idx="3">
+            <a:schemeClr val="accent1"/>
+          </a:fillRef>
+          <a:effectRef idx="2">
+            <a:schemeClr val="accent1"/>
+          </a:effectRef>
+          <a:fontRef idx="minor">
+            <a:schemeClr val="lt1"/>
+          </a:fontRef>
+        </p:style>
+        <p:txBody>
+          <a:bodyPr rtlCol="0" anchor="ctr" wrap="square" lIns="182880" rIns="182880" tIns="182880"/>
+          <a:lstStyle/>
+          <a:p>
+            <a:pPr algn="ctr">
+              <a:spcAft>
+                <a:spcPts val="600"/>
+              </a:spcAft>
+              <a:defRPr sz="1200" b="1">
+                <a:solidFill>
+                  <a:srgbClr val="4F46E5"/>
+                </a:solidFill>
+              </a:defRPr>
+            </a:pPr>
+            <a:r>
+              <a:t>24/7 Context-Aware AI Chatbot</a:t>
+            </a:r>
+          </a:p>
+          <a:p>
+            <a:pPr>
+              <a:lnSpc>
+                <a:spcPct val="115000"/>
+              </a:lnSpc>
+              <a:defRPr sz="1000">
+                <a:solidFill>
+                  <a:srgbClr val="334155"/>
+                </a:solidFill>
+              </a:defRPr>
+            </a:pPr>
+            <a:r>
+              <a:t>Intelligent tutor providing code blocks with copy buttons, comparisons, and exam tips.</a:t>
+            </a:r>
+          </a:p>
+        </p:txBody>
+      </p:sp>
+      <p:sp>
+        <p:nvSpPr>
+          <p:cNvPr id="9" name="Rounded Rectangle 8"/>
+          <p:cNvSpPr/>
+          <p:nvPr/>
+        </p:nvSpPr>
+        <p:spPr>
+          <a:xfrm>
+            <a:off x="3474720" y="3977639"/>
+            <a:ext cx="2514600" cy="2148840"/>
+          </a:xfrm>
+          <a:prstGeom prst="roundRect">
+            <a:avLst/>
+          </a:prstGeom>
+          <a:solidFill>
+            <a:srgbClr val="FFFFFF"/>
+          </a:solidFill>
+          <a:ln>
+            <a:solidFill>
+              <a:srgbClr val="E2E8F0"/>
+            </a:solidFill>
+          </a:ln>
+        </p:spPr>
+        <p:style>
+          <a:lnRef idx="1">
+            <a:schemeClr val="accent1"/>
+          </a:lnRef>
+          <a:fillRef idx="3">
+            <a:schemeClr val="accent1"/>
+          </a:fillRef>
+          <a:effectRef idx="2">
+            <a:schemeClr val="accent1"/>
+          </a:effectRef>
+          <a:fontRef idx="minor">
+            <a:schemeClr val="lt1"/>
+          </a:fontRef>
+        </p:style>
+        <p:txBody>
+          <a:bodyPr rtlCol="0" anchor="ctr" wrap="square" lIns="182880" rIns="182880" tIns="182880"/>
+          <a:lstStyle/>
+          <a:p>
+            <a:pPr algn="ctr">
+              <a:spcAft>
+                <a:spcPts val="600"/>
+              </a:spcAft>
+              <a:defRPr sz="1200" b="1">
+                <a:solidFill>
+                  <a:srgbClr val="0284C7"/>
+                </a:solidFill>
+              </a:defRPr>
+            </a:pPr>
+            <a:r>
+              <a:t>ATS Resume Builder &amp; Scoring</a:t>
+            </a:r>
+          </a:p>
+          <a:p>
+            <a:pPr>
+              <a:lnSpc>
+                <a:spcPct val="115000"/>
+              </a:lnSpc>
+              <a:defRPr sz="1000">
+                <a:solidFill>
+                  <a:srgbClr val="334155"/>
+                </a:solidFill>
+              </a:defRPr>
+            </a:pPr>
+            <a:r>
+              <a:t>Instant ATS score calculation, Google XYZ bullet optimizers, and 1-click PDF download.</a:t>
+            </a:r>
+          </a:p>
+        </p:txBody>
+      </p:sp>
+      <p:sp>
+        <p:nvSpPr>
+          <p:cNvPr id="10" name="Rounded Rectangle 9"/>
+          <p:cNvSpPr/>
+          <p:nvPr/>
+        </p:nvSpPr>
+        <p:spPr>
+          <a:xfrm>
+            <a:off x="6126480" y="3977639"/>
+            <a:ext cx="2514600" cy="2148840"/>
+          </a:xfrm>
+          <a:prstGeom prst="roundRect">
+            <a:avLst/>
+          </a:prstGeom>
+          <a:solidFill>
+            <a:srgbClr val="FFFFFF"/>
+          </a:solidFill>
+          <a:ln>
+            <a:solidFill>
+              <a:srgbClr val="E2E8F0"/>
+            </a:solidFill>
+          </a:ln>
+        </p:spPr>
+        <p:style>
+          <a:lnRef idx="1">
+            <a:schemeClr val="accent1"/>
+          </a:lnRef>
+          <a:fillRef idx="3">
+            <a:schemeClr val="accent1"/>
+          </a:fillRef>
+          <a:effectRef idx="2">
+            <a:schemeClr val="accent1"/>
+          </a:effectRef>
+          <a:fontRef idx="minor">
+            <a:schemeClr val="lt1"/>
+          </a:fontRef>
+        </p:style>
+        <p:txBody>
+          <a:bodyPr rtlCol="0" anchor="ctr" wrap="square" lIns="182880" rIns="182880" tIns="182880"/>
+          <a:lstStyle/>
+          <a:p>
+            <a:pPr algn="ctr">
+              <a:spcAft>
+                <a:spcPts val="600"/>
+              </a:spcAft>
+              <a:defRPr sz="1200" b="1">
+                <a:solidFill>
+                  <a:srgbClr val="0D9488"/>
+                </a:solidFill>
+              </a:defRPr>
+            </a:pPr>
+            <a:r>
+              <a:t>What-If Scenario Simulator</a:t>
+            </a:r>
+          </a:p>
+          <a:p>
+            <a:pPr>
+              <a:lnSpc>
+                <a:spcPct val="115000"/>
+              </a:lnSpc>
+              <a:defRPr sz="1000">
+                <a:solidFill>
+                  <a:srgbClr val="334155"/>
+                </a:solidFill>
+              </a:defRPr>
+            </a:pPr>
+            <a:r>
+              <a:t>Interactive time-commitment slider modeling how study pacing impacts target completion.</a:t>
+            </a:r>
+          </a:p>
+        </p:txBody>
+      </p:sp>
+      <p:sp>
+        <p:nvSpPr>
+          <p:cNvPr id="11" name="Rounded Rectangle 10"/>
+          <p:cNvSpPr/>
+          <p:nvPr/>
+        </p:nvSpPr>
+        <p:spPr>
+          <a:xfrm>
+            <a:off x="8778240" y="3977639"/>
+            <a:ext cx="2514600" cy="2148840"/>
+          </a:xfrm>
+          <a:prstGeom prst="roundRect">
+            <a:avLst/>
+          </a:prstGeom>
+          <a:solidFill>
+            <a:srgbClr val="FFFFFF"/>
+          </a:solidFill>
+          <a:ln>
+            <a:solidFill>
+              <a:srgbClr val="E2E8F0"/>
+            </a:solidFill>
+          </a:ln>
+        </p:spPr>
+        <p:style>
+          <a:lnRef idx="1">
+            <a:schemeClr val="accent1"/>
+          </a:lnRef>
+          <a:fillRef idx="3">
+            <a:schemeClr val="accent1"/>
+          </a:fillRef>
+          <a:effectRef idx="2">
+            <a:schemeClr val="accent1"/>
+          </a:effectRef>
+          <a:fontRef idx="minor">
+            <a:schemeClr val="lt1"/>
+          </a:fontRef>
+        </p:style>
+        <p:txBody>
+          <a:bodyPr rtlCol="0" anchor="ctr" wrap="square" lIns="182880" rIns="182880" tIns="182880"/>
+          <a:lstStyle/>
+          <a:p>
+            <a:pPr algn="ctr">
+              <a:spcAft>
+                <a:spcPts val="600"/>
+              </a:spcAft>
+              <a:defRPr sz="1200" b="1">
+                <a:solidFill>
+                  <a:srgbClr val="0F172A"/>
+                </a:solidFill>
+              </a:defRPr>
+            </a:pPr>
+            <a:r>
+              <a:t>100% Free Resources Catalog</a:t>
+            </a:r>
+          </a:p>
+          <a:p>
+            <a:pPr>
+              <a:lnSpc>
+                <a:spcPct val="115000"/>
+              </a:lnSpc>
+              <a:defRPr sz="1000">
+                <a:solidFill>
+                  <a:srgbClr val="334155"/>
+                </a:solidFill>
+              </a:defRPr>
+            </a:pPr>
+            <a:r>
+              <a:t>Curated zero-cost materials from MIT OpenCourseWare, CS50, Disha, HCV, &amp; freeCodeCamp.</a:t>
+            </a:r>
+          </a:p>
+        </p:txBody>
+      </p:sp>
+    </p:spTree>
+  </p:cSld>
+  <p:clrMapOvr>
+    <a:masterClrMapping/>
+  </p:clrMapOvr>
+</p:sld>
+</file>
+
+<file path=ppt/slides/slide9.xml><?xml version="1.0" encoding="utf-8"?>
+<p:sld xmlns:a="http://schemas.openxmlformats.org/drawingml/2006/main" xmlns:p="http://schemas.openxmlformats.org/presentationml/2006/main" xmlns:r="http://schemas.openxmlformats.org/officeDocument/2006/relationships">
+  <p:cSld>
+    <p:spTree>
+      <p:nvGrpSpPr>
+        <p:cNvPr id="1" name=""/>
+        <p:cNvGrpSpPr/>
+        <p:nvPr/>
+      </p:nvGrpSpPr>
+      <p:grpSpPr/>
+      <p:sp>
+        <p:nvSpPr>
+          <p:cNvPr id="2" name="Rectangle 1"/>
+          <p:cNvSpPr/>
+          <p:nvPr/>
+        </p:nvSpPr>
+        <p:spPr>
+          <a:xfrm>
+            <a:off x="0" y="0"/>
+            <a:ext cx="12191695" cy="6858000"/>
+          </a:xfrm>
+          <a:prstGeom prst="rect">
+            <a:avLst/>
+          </a:prstGeom>
+          <a:solidFill>
+            <a:srgbClr val="F8FAFC"/>
+          </a:solidFill>
+          <a:ln>
+            <a:solidFill>
+              <a:srgbClr val="F8FAFC"/>
+            </a:solidFill>
+          </a:ln>
+        </p:spPr>
+        <p:style>
+          <a:lnRef idx="1">
+            <a:schemeClr val="accent1"/>
+          </a:lnRef>
+          <a:fillRef idx="3">
+            <a:schemeClr val="accent1"/>
+          </a:fillRef>
+          <a:effectRef idx="2">
+            <a:schemeClr val="accent1"/>
+          </a:effectRef>
+          <a:fontRef idx="minor">
+            <a:schemeClr val="lt1"/>
+          </a:fontRef>
+        </p:style>
+        <p:txBody>
+          <a:bodyPr rtlCol="0" anchor="ctr"/>
+          <a:lstStyle/>
+          <a:p>
+            <a:pPr algn="ctr"/>
+          </a:p>
+        </p:txBody>
+      </p:sp>
+      <p:sp>
+        <p:nvSpPr>
           <p:cNvPr id="3" name="Rounded Rectangle 2"/>
           <p:cNvSpPr/>
           <p:nvPr/>
         </p:nvSpPr>
         <p:spPr>
           <a:xfrm>
-            <a:off x="914400" y="1005840"/>
-            <a:ext cx="10362895" cy="4937760"/>
+            <a:off x="914400" y="914400"/>
+            <a:ext cx="10362895" cy="5120640"/>
           </a:xfrm>
           <a:prstGeom prst="roundRect">
             <a:avLst/>

</xml_diff>